<commit_message>
Gross YOY charts: 2025 line stops at September like every other YOY chart
Co-Authored-By: Claude Opus 5.5 <noreply@anthropic.com>
Claude-Session: https://claude.ai/code/session_01Xa4nFVxuQGXmHARGph9WhS
</commit_message>
<xml_diff>
--- a/day2-deck/decks/Fixed Ops Gross - House Style.pptx
+++ b/day2-deck/decks/Fixed Ops Gross - House Style.pptx
@@ -198,9 +198,9 @@
           </c:marker>
           <c:cat>
             <c:multiLvlStrRef>
-              <c:f>Sheet1!$A$2:$A$13</c:f>
+              <c:f>Sheet1!$A$2:$A$10</c:f>
               <c:multiLvlStrCache>
-                <c:ptCount val="12"/>
+                <c:ptCount val="9"/>
                 <c:lvl>
                   <c:pt idx="0">
                     <c:v>Jan</c:v>
@@ -229,25 +229,16 @@
                   <c:pt idx="8">
                     <c:v>Sep</c:v>
                   </c:pt>
-                  <c:pt idx="9">
-                    <c:v>Oct</c:v>
-                  </c:pt>
-                  <c:pt idx="10">
-                    <c:v>Nov</c:v>
-                  </c:pt>
-                  <c:pt idx="11">
-                    <c:v>Dec</c:v>
-                  </c:pt>
                 </c:lvl>
               </c:multiLvlStrCache>
             </c:multiLvlStrRef>
           </c:cat>
           <c:val>
             <c:numRef>
-              <c:f>Sheet1!$B$2:$B$13</c:f>
+              <c:f>Sheet1!$B$2:$B$10</c:f>
               <c:numCache>
                 <c:formatCode>General</c:formatCode>
-                <c:ptCount val="12"/>
+                <c:ptCount val="9"/>
                 <c:pt idx="0">
                   <c:v>19.88</c:v>
                 </c:pt>
@@ -274,15 +265,6 @@
                 </c:pt>
                 <c:pt idx="8">
                   <c:v>21.13</c:v>
-                </c:pt>
-                <c:pt idx="9">
-                  <c:v/>
-                </c:pt>
-                <c:pt idx="10">
-                  <c:v/>
-                </c:pt>
-                <c:pt idx="11">
-                  <c:v/>
                 </c:pt>
               </c:numCache>
             </c:numRef>
@@ -502,9 +484,9 @@
           </c:marker>
           <c:cat>
             <c:multiLvlStrRef>
-              <c:f>Sheet1!$A$2:$A$13</c:f>
+              <c:f>Sheet1!$A$2:$A$10</c:f>
               <c:multiLvlStrCache>
-                <c:ptCount val="12"/>
+                <c:ptCount val="9"/>
                 <c:lvl>
                   <c:pt idx="0">
                     <c:v>Jan</c:v>
@@ -533,25 +515,16 @@
                   <c:pt idx="8">
                     <c:v>Sep</c:v>
                   </c:pt>
-                  <c:pt idx="9">
-                    <c:v>Oct</c:v>
-                  </c:pt>
-                  <c:pt idx="10">
-                    <c:v>Nov</c:v>
-                  </c:pt>
-                  <c:pt idx="11">
-                    <c:v>Dec</c:v>
-                  </c:pt>
                 </c:lvl>
               </c:multiLvlStrCache>
             </c:multiLvlStrRef>
           </c:cat>
           <c:val>
             <c:numRef>
-              <c:f>Sheet1!$B$2:$B$13</c:f>
+              <c:f>Sheet1!$B$2:$B$10</c:f>
               <c:numCache>
                 <c:formatCode>General</c:formatCode>
-                <c:ptCount val="12"/>
+                <c:ptCount val="9"/>
                 <c:pt idx="0">
                   <c:v>13.41</c:v>
                 </c:pt>
@@ -578,15 +551,6 @@
                 </c:pt>
                 <c:pt idx="8">
                   <c:v>12.5</c:v>
-                </c:pt>
-                <c:pt idx="9">
-                  <c:v>13.74</c:v>
-                </c:pt>
-                <c:pt idx="10">
-                  <c:v>11.84</c:v>
-                </c:pt>
-                <c:pt idx="11">
-                  <c:v>12.92</c:v>
                 </c:pt>
               </c:numCache>
             </c:numRef>
@@ -667,8 +631,8 @@
         <c:axId val="2094734552"/>
         <c:scaling>
           <c:orientation val="minMax"/>
-          <c:max val="18"/>
-          <c:min val="10"/>
+          <c:max val="16"/>
+          <c:min val="11"/>
         </c:scaling>
         <c:delete val="0"/>
         <c:axPos val="l"/>
@@ -712,7 +676,7 @@
         <c:crossAx val="2094734554"/>
         <c:crosses val="autoZero"/>
         <c:crossBetween val="between"/>
-        <c:majorUnit val="2"/>
+        <c:majorUnit val="1"/>
       </c:valAx>
       <c:spPr>
         <a:solidFill>
@@ -827,9 +791,9 @@
           </c:marker>
           <c:cat>
             <c:multiLvlStrRef>
-              <c:f>Sheet1!$A$2:$A$13</c:f>
+              <c:f>Sheet1!$A$2:$A$10</c:f>
               <c:multiLvlStrCache>
-                <c:ptCount val="12"/>
+                <c:ptCount val="9"/>
                 <c:lvl>
                   <c:pt idx="0">
                     <c:v>Jan</c:v>
@@ -858,25 +822,16 @@
                   <c:pt idx="8">
                     <c:v>Sep</c:v>
                   </c:pt>
-                  <c:pt idx="9">
-                    <c:v>Oct</c:v>
-                  </c:pt>
-                  <c:pt idx="10">
-                    <c:v>Nov</c:v>
-                  </c:pt>
-                  <c:pt idx="11">
-                    <c:v>Dec</c:v>
-                  </c:pt>
                 </c:lvl>
               </c:multiLvlStrCache>
             </c:multiLvlStrRef>
           </c:cat>
           <c:val>
             <c:numRef>
-              <c:f>Sheet1!$B$2:$B$13</c:f>
+              <c:f>Sheet1!$B$2:$B$10</c:f>
               <c:numCache>
                 <c:formatCode>General</c:formatCode>
-                <c:ptCount val="12"/>
+                <c:ptCount val="9"/>
                 <c:pt idx="0">
                   <c:v>6.41</c:v>
                 </c:pt>
@@ -903,15 +858,6 @@
                 </c:pt>
                 <c:pt idx="8">
                   <c:v>7.18</c:v>
-                </c:pt>
-                <c:pt idx="9">
-                  <c:v/>
-                </c:pt>
-                <c:pt idx="10">
-                  <c:v/>
-                </c:pt>
-                <c:pt idx="11">
-                  <c:v/>
                 </c:pt>
               </c:numCache>
             </c:numRef>
@@ -1128,9 +1074,9 @@
           </c:marker>
           <c:cat>
             <c:multiLvlStrRef>
-              <c:f>Sheet1!$A$2:$A$13</c:f>
+              <c:f>Sheet1!$A$2:$A$10</c:f>
               <c:multiLvlStrCache>
-                <c:ptCount val="12"/>
+                <c:ptCount val="9"/>
                 <c:lvl>
                   <c:pt idx="0">
                     <c:v>Jan</c:v>
@@ -1159,25 +1105,16 @@
                   <c:pt idx="8">
                     <c:v>Sep</c:v>
                   </c:pt>
-                  <c:pt idx="9">
-                    <c:v>Oct</c:v>
-                  </c:pt>
-                  <c:pt idx="10">
-                    <c:v>Nov</c:v>
-                  </c:pt>
-                  <c:pt idx="11">
-                    <c:v>Dec</c:v>
-                  </c:pt>
                 </c:lvl>
               </c:multiLvlStrCache>
             </c:multiLvlStrRef>
           </c:cat>
           <c:val>
             <c:numRef>
-              <c:f>Sheet1!$B$2:$B$13</c:f>
+              <c:f>Sheet1!$B$2:$B$10</c:f>
               <c:numCache>
                 <c:formatCode>General</c:formatCode>
-                <c:ptCount val="12"/>
+                <c:ptCount val="9"/>
                 <c:pt idx="0">
                   <c:v/>
                 </c:pt>
@@ -1204,15 +1141,6 @@
                 </c:pt>
                 <c:pt idx="8">
                   <c:v>7.18</c:v>
-                </c:pt>
-                <c:pt idx="9">
-                  <c:v/>
-                </c:pt>
-                <c:pt idx="10">
-                  <c:v/>
-                </c:pt>
-                <c:pt idx="11">
-                  <c:v/>
                 </c:pt>
               </c:numCache>
             </c:numRef>
@@ -1438,9 +1366,9 @@
           </c:marker>
           <c:cat>
             <c:multiLvlStrRef>
-              <c:f>Sheet1!$A$2:$A$13</c:f>
+              <c:f>Sheet1!$A$2:$A$10</c:f>
               <c:multiLvlStrCache>
-                <c:ptCount val="12"/>
+                <c:ptCount val="9"/>
                 <c:lvl>
                   <c:pt idx="0">
                     <c:v>Jan</c:v>
@@ -1469,25 +1397,16 @@
                   <c:pt idx="8">
                     <c:v>Sep</c:v>
                   </c:pt>
-                  <c:pt idx="9">
-                    <c:v>Oct</c:v>
-                  </c:pt>
-                  <c:pt idx="10">
-                    <c:v>Nov</c:v>
-                  </c:pt>
-                  <c:pt idx="11">
-                    <c:v>Dec</c:v>
-                  </c:pt>
                 </c:lvl>
               </c:multiLvlStrCache>
             </c:multiLvlStrRef>
           </c:cat>
           <c:val>
             <c:numRef>
-              <c:f>Sheet1!$B$2:$B$13</c:f>
+              <c:f>Sheet1!$B$2:$B$10</c:f>
               <c:numCache>
                 <c:formatCode>General</c:formatCode>
-                <c:ptCount val="12"/>
+                <c:ptCount val="9"/>
                 <c:pt idx="0">
                   <c:v>6.41</c:v>
                 </c:pt>
@@ -1513,15 +1432,6 @@
                   <c:v/>
                 </c:pt>
                 <c:pt idx="8">
-                  <c:v/>
-                </c:pt>
-                <c:pt idx="9">
-                  <c:v/>
-                </c:pt>
-                <c:pt idx="10">
-                  <c:v/>
-                </c:pt>
-                <c:pt idx="11">
                   <c:v/>
                 </c:pt>
               </c:numCache>
@@ -1748,9 +1658,9 @@
           </c:marker>
           <c:cat>
             <c:multiLvlStrRef>
-              <c:f>Sheet1!$A$2:$A$13</c:f>
+              <c:f>Sheet1!$A$2:$A$10</c:f>
               <c:multiLvlStrCache>
-                <c:ptCount val="12"/>
+                <c:ptCount val="9"/>
                 <c:lvl>
                   <c:pt idx="0">
                     <c:v>Jan</c:v>
@@ -1779,25 +1689,16 @@
                   <c:pt idx="8">
                     <c:v>Sep</c:v>
                   </c:pt>
-                  <c:pt idx="9">
-                    <c:v>Oct</c:v>
-                  </c:pt>
-                  <c:pt idx="10">
-                    <c:v>Nov</c:v>
-                  </c:pt>
-                  <c:pt idx="11">
-                    <c:v>Dec</c:v>
-                  </c:pt>
                 </c:lvl>
               </c:multiLvlStrCache>
             </c:multiLvlStrRef>
           </c:cat>
           <c:val>
             <c:numRef>
-              <c:f>Sheet1!$B$2:$B$13</c:f>
+              <c:f>Sheet1!$B$2:$B$10</c:f>
               <c:numCache>
                 <c:formatCode>General</c:formatCode>
-                <c:ptCount val="12"/>
+                <c:ptCount val="9"/>
                 <c:pt idx="0">
                   <c:v>7.05</c:v>
                 </c:pt>
@@ -1823,15 +1724,6 @@
                   <c:v/>
                 </c:pt>
                 <c:pt idx="8">
-                  <c:v/>
-                </c:pt>
-                <c:pt idx="9">
-                  <c:v/>
-                </c:pt>
-                <c:pt idx="10">
-                  <c:v/>
-                </c:pt>
-                <c:pt idx="11">
                   <c:v/>
                 </c:pt>
               </c:numCache>
@@ -2058,9 +1950,9 @@
           </c:marker>
           <c:cat>
             <c:multiLvlStrRef>
-              <c:f>Sheet1!$A$2:$A$13</c:f>
+              <c:f>Sheet1!$A$2:$A$10</c:f>
               <c:multiLvlStrCache>
-                <c:ptCount val="12"/>
+                <c:ptCount val="9"/>
                 <c:lvl>
                   <c:pt idx="0">
                     <c:v>Jan</c:v>
@@ -2089,25 +1981,16 @@
                   <c:pt idx="8">
                     <c:v>Sep</c:v>
                   </c:pt>
-                  <c:pt idx="9">
-                    <c:v>Oct</c:v>
-                  </c:pt>
-                  <c:pt idx="10">
-                    <c:v>Nov</c:v>
-                  </c:pt>
-                  <c:pt idx="11">
-                    <c:v>Dec</c:v>
-                  </c:pt>
                 </c:lvl>
               </c:multiLvlStrCache>
             </c:multiLvlStrRef>
           </c:cat>
           <c:val>
             <c:numRef>
-              <c:f>Sheet1!$B$2:$B$13</c:f>
+              <c:f>Sheet1!$B$2:$B$10</c:f>
               <c:numCache>
                 <c:formatCode>General</c:formatCode>
-                <c:ptCount val="12"/>
+                <c:ptCount val="9"/>
                 <c:pt idx="0">
                   <c:v/>
                 </c:pt>
@@ -2134,15 +2017,6 @@
                 </c:pt>
                 <c:pt idx="8">
                   <c:v>6.54</c:v>
-                </c:pt>
-                <c:pt idx="9">
-                  <c:v>7.53</c:v>
-                </c:pt>
-                <c:pt idx="10">
-                  <c:v>5.91</c:v>
-                </c:pt>
-                <c:pt idx="11">
-                  <c:v>6.4</c:v>
                 </c:pt>
               </c:numCache>
             </c:numRef>
@@ -2371,9 +2245,9 @@
           </c:marker>
           <c:cat>
             <c:multiLvlStrRef>
-              <c:f>Sheet1!$A$2:$A$13</c:f>
+              <c:f>Sheet1!$A$2:$A$10</c:f>
               <c:multiLvlStrCache>
-                <c:ptCount val="12"/>
+                <c:ptCount val="9"/>
                 <c:lvl>
                   <c:pt idx="0">
                     <c:v>Jan</c:v>
@@ -2402,25 +2276,16 @@
                   <c:pt idx="8">
                     <c:v>Sep</c:v>
                   </c:pt>
-                  <c:pt idx="9">
-                    <c:v>Oct</c:v>
-                  </c:pt>
-                  <c:pt idx="10">
-                    <c:v>Nov</c:v>
-                  </c:pt>
-                  <c:pt idx="11">
-                    <c:v>Dec</c:v>
-                  </c:pt>
                 </c:lvl>
               </c:multiLvlStrCache>
             </c:multiLvlStrRef>
           </c:cat>
           <c:val>
             <c:numRef>
-              <c:f>Sheet1!$B$2:$B$13</c:f>
+              <c:f>Sheet1!$B$2:$B$10</c:f>
               <c:numCache>
                 <c:formatCode>General</c:formatCode>
-                <c:ptCount val="12"/>
+                <c:ptCount val="9"/>
                 <c:pt idx="0">
                   <c:v>7.05</c:v>
                 </c:pt>
@@ -2447,15 +2312,6 @@
                 </c:pt>
                 <c:pt idx="8">
                   <c:v>6.54</c:v>
-                </c:pt>
-                <c:pt idx="9">
-                  <c:v>7.53</c:v>
-                </c:pt>
-                <c:pt idx="10">
-                  <c:v>5.91</c:v>
-                </c:pt>
-                <c:pt idx="11">
-                  <c:v>6.4</c:v>
                 </c:pt>
               </c:numCache>
             </c:numRef>
@@ -2693,9 +2549,9 @@
           </c:marker>
           <c:cat>
             <c:multiLvlStrRef>
-              <c:f>Sheet1!$A$2:$A$13</c:f>
+              <c:f>Sheet1!$A$2:$A$10</c:f>
               <c:multiLvlStrCache>
-                <c:ptCount val="12"/>
+                <c:ptCount val="9"/>
                 <c:lvl>
                   <c:pt idx="0">
                     <c:v>Jan</c:v>
@@ -2724,25 +2580,16 @@
                   <c:pt idx="8">
                     <c:v>Sep</c:v>
                   </c:pt>
-                  <c:pt idx="9">
-                    <c:v>Oct</c:v>
-                  </c:pt>
-                  <c:pt idx="10">
-                    <c:v>Nov</c:v>
-                  </c:pt>
-                  <c:pt idx="11">
-                    <c:v>Dec</c:v>
-                  </c:pt>
                 </c:lvl>
               </c:multiLvlStrCache>
             </c:multiLvlStrRef>
           </c:cat>
           <c:val>
             <c:numRef>
-              <c:f>Sheet1!$B$2:$B$13</c:f>
+              <c:f>Sheet1!$B$2:$B$10</c:f>
               <c:numCache>
                 <c:formatCode>General</c:formatCode>
-                <c:ptCount val="12"/>
+                <c:ptCount val="9"/>
                 <c:pt idx="0">
                   <c:v/>
                 </c:pt>
@@ -2769,15 +2616,6 @@
                 </c:pt>
                 <c:pt idx="8">
                   <c:v>21.13</c:v>
-                </c:pt>
-                <c:pt idx="9">
-                  <c:v/>
-                </c:pt>
-                <c:pt idx="10">
-                  <c:v/>
-                </c:pt>
-                <c:pt idx="11">
-                  <c:v/>
                 </c:pt>
               </c:numCache>
             </c:numRef>
@@ -3003,9 +2841,9 @@
           </c:marker>
           <c:cat>
             <c:multiLvlStrRef>
-              <c:f>Sheet1!$A$2:$A$13</c:f>
+              <c:f>Sheet1!$A$2:$A$10</c:f>
               <c:multiLvlStrCache>
-                <c:ptCount val="12"/>
+                <c:ptCount val="9"/>
                 <c:lvl>
                   <c:pt idx="0">
                     <c:v>Jan</c:v>
@@ -3034,25 +2872,16 @@
                   <c:pt idx="8">
                     <c:v>Sep</c:v>
                   </c:pt>
-                  <c:pt idx="9">
-                    <c:v>Oct</c:v>
-                  </c:pt>
-                  <c:pt idx="10">
-                    <c:v>Nov</c:v>
-                  </c:pt>
-                  <c:pt idx="11">
-                    <c:v>Dec</c:v>
-                  </c:pt>
                 </c:lvl>
               </c:multiLvlStrCache>
             </c:multiLvlStrRef>
           </c:cat>
           <c:val>
             <c:numRef>
-              <c:f>Sheet1!$B$2:$B$13</c:f>
+              <c:f>Sheet1!$B$2:$B$10</c:f>
               <c:numCache>
                 <c:formatCode>General</c:formatCode>
-                <c:ptCount val="12"/>
+                <c:ptCount val="9"/>
                 <c:pt idx="0">
                   <c:v>19.88</c:v>
                 </c:pt>
@@ -3078,15 +2907,6 @@
                   <c:v/>
                 </c:pt>
                 <c:pt idx="8">
-                  <c:v/>
-                </c:pt>
-                <c:pt idx="9">
-                  <c:v/>
-                </c:pt>
-                <c:pt idx="10">
-                  <c:v/>
-                </c:pt>
-                <c:pt idx="11">
                   <c:v/>
                 </c:pt>
               </c:numCache>
@@ -3313,9 +3133,9 @@
           </c:marker>
           <c:cat>
             <c:multiLvlStrRef>
-              <c:f>Sheet1!$A$2:$A$13</c:f>
+              <c:f>Sheet1!$A$2:$A$10</c:f>
               <c:multiLvlStrCache>
-                <c:ptCount val="12"/>
+                <c:ptCount val="9"/>
                 <c:lvl>
                   <c:pt idx="0">
                     <c:v>Jan</c:v>
@@ -3344,25 +3164,16 @@
                   <c:pt idx="8">
                     <c:v>Sep</c:v>
                   </c:pt>
-                  <c:pt idx="9">
-                    <c:v>Oct</c:v>
-                  </c:pt>
-                  <c:pt idx="10">
-                    <c:v>Nov</c:v>
-                  </c:pt>
-                  <c:pt idx="11">
-                    <c:v>Dec</c:v>
-                  </c:pt>
                 </c:lvl>
               </c:multiLvlStrCache>
             </c:multiLvlStrRef>
           </c:cat>
           <c:val>
             <c:numRef>
-              <c:f>Sheet1!$B$2:$B$13</c:f>
+              <c:f>Sheet1!$B$2:$B$10</c:f>
               <c:numCache>
                 <c:formatCode>General</c:formatCode>
-                <c:ptCount val="12"/>
+                <c:ptCount val="9"/>
                 <c:pt idx="0">
                   <c:v>20.46</c:v>
                 </c:pt>
@@ -3388,15 +3199,6 @@
                   <c:v/>
                 </c:pt>
                 <c:pt idx="8">
-                  <c:v/>
-                </c:pt>
-                <c:pt idx="9">
-                  <c:v/>
-                </c:pt>
-                <c:pt idx="10">
-                  <c:v/>
-                </c:pt>
-                <c:pt idx="11">
                   <c:v/>
                 </c:pt>
               </c:numCache>
@@ -3623,9 +3425,9 @@
           </c:marker>
           <c:cat>
             <c:multiLvlStrRef>
-              <c:f>Sheet1!$A$2:$A$13</c:f>
+              <c:f>Sheet1!$A$2:$A$10</c:f>
               <c:multiLvlStrCache>
-                <c:ptCount val="12"/>
+                <c:ptCount val="9"/>
                 <c:lvl>
                   <c:pt idx="0">
                     <c:v>Jan</c:v>
@@ -3654,25 +3456,16 @@
                   <c:pt idx="8">
                     <c:v>Sep</c:v>
                   </c:pt>
-                  <c:pt idx="9">
-                    <c:v>Oct</c:v>
-                  </c:pt>
-                  <c:pt idx="10">
-                    <c:v>Nov</c:v>
-                  </c:pt>
-                  <c:pt idx="11">
-                    <c:v>Dec</c:v>
-                  </c:pt>
                 </c:lvl>
               </c:multiLvlStrCache>
             </c:multiLvlStrRef>
           </c:cat>
           <c:val>
             <c:numRef>
-              <c:f>Sheet1!$B$2:$B$13</c:f>
+              <c:f>Sheet1!$B$2:$B$10</c:f>
               <c:numCache>
                 <c:formatCode>General</c:formatCode>
-                <c:ptCount val="12"/>
+                <c:ptCount val="9"/>
                 <c:pt idx="0">
                   <c:v/>
                 </c:pt>
@@ -3699,15 +3492,6 @@
                 </c:pt>
                 <c:pt idx="8">
                   <c:v>19.03</c:v>
-                </c:pt>
-                <c:pt idx="9">
-                  <c:v>21.27</c:v>
-                </c:pt>
-                <c:pt idx="10">
-                  <c:v>17.74</c:v>
-                </c:pt>
-                <c:pt idx="11">
-                  <c:v>19.32</c:v>
                 </c:pt>
               </c:numCache>
             </c:numRef>
@@ -3936,9 +3720,9 @@
           </c:marker>
           <c:cat>
             <c:multiLvlStrRef>
-              <c:f>Sheet1!$A$2:$A$13</c:f>
+              <c:f>Sheet1!$A$2:$A$10</c:f>
               <c:multiLvlStrCache>
-                <c:ptCount val="12"/>
+                <c:ptCount val="9"/>
                 <c:lvl>
                   <c:pt idx="0">
                     <c:v>Jan</c:v>
@@ -3967,25 +3751,16 @@
                   <c:pt idx="8">
                     <c:v>Sep</c:v>
                   </c:pt>
-                  <c:pt idx="9">
-                    <c:v>Oct</c:v>
-                  </c:pt>
-                  <c:pt idx="10">
-                    <c:v>Nov</c:v>
-                  </c:pt>
-                  <c:pt idx="11">
-                    <c:v>Dec</c:v>
-                  </c:pt>
                 </c:lvl>
               </c:multiLvlStrCache>
             </c:multiLvlStrRef>
           </c:cat>
           <c:val>
             <c:numRef>
-              <c:f>Sheet1!$B$2:$B$13</c:f>
+              <c:f>Sheet1!$B$2:$B$10</c:f>
               <c:numCache>
                 <c:formatCode>General</c:formatCode>
-                <c:ptCount val="12"/>
+                <c:ptCount val="9"/>
                 <c:pt idx="0">
                   <c:v>20.46</c:v>
                 </c:pt>
@@ -4012,15 +3787,6 @@
                 </c:pt>
                 <c:pt idx="8">
                   <c:v>19.03</c:v>
-                </c:pt>
-                <c:pt idx="9">
-                  <c:v>21.27</c:v>
-                </c:pt>
-                <c:pt idx="10">
-                  <c:v>17.74</c:v>
-                </c:pt>
-                <c:pt idx="11">
-                  <c:v>19.32</c:v>
                 </c:pt>
               </c:numCache>
             </c:numRef>
@@ -4261,9 +4027,9 @@
           </c:marker>
           <c:cat>
             <c:multiLvlStrRef>
-              <c:f>Sheet1!$A$2:$A$13</c:f>
+              <c:f>Sheet1!$A$2:$A$10</c:f>
               <c:multiLvlStrCache>
-                <c:ptCount val="12"/>
+                <c:ptCount val="9"/>
                 <c:lvl>
                   <c:pt idx="0">
                     <c:v>Jan</c:v>
@@ -4292,25 +4058,16 @@
                   <c:pt idx="8">
                     <c:v>Sep</c:v>
                   </c:pt>
-                  <c:pt idx="9">
-                    <c:v>Oct</c:v>
-                  </c:pt>
-                  <c:pt idx="10">
-                    <c:v>Nov</c:v>
-                  </c:pt>
-                  <c:pt idx="11">
-                    <c:v>Dec</c:v>
-                  </c:pt>
                 </c:lvl>
               </c:multiLvlStrCache>
             </c:multiLvlStrRef>
           </c:cat>
           <c:val>
             <c:numRef>
-              <c:f>Sheet1!$B$2:$B$13</c:f>
+              <c:f>Sheet1!$B$2:$B$10</c:f>
               <c:numCache>
                 <c:formatCode>General</c:formatCode>
-                <c:ptCount val="12"/>
+                <c:ptCount val="9"/>
                 <c:pt idx="0">
                   <c:v>13.47</c:v>
                 </c:pt>
@@ -4337,15 +4094,6 @@
                 </c:pt>
                 <c:pt idx="8">
                   <c:v>13.96</c:v>
-                </c:pt>
-                <c:pt idx="9">
-                  <c:v/>
-                </c:pt>
-                <c:pt idx="10">
-                  <c:v/>
-                </c:pt>
-                <c:pt idx="11">
-                  <c:v/>
                 </c:pt>
               </c:numCache>
             </c:numRef>
@@ -4424,8 +4172,8 @@
         <c:axId val="2094734552"/>
         <c:scaling>
           <c:orientation val="minMax"/>
-          <c:max val="18"/>
-          <c:min val="10"/>
+          <c:max val="16"/>
+          <c:min val="11"/>
         </c:scaling>
         <c:delete val="0"/>
         <c:axPos val="l"/>
@@ -4458,7 +4206,7 @@
         <c:crossAx val="2094734554"/>
         <c:crosses val="autoZero"/>
         <c:crossBetween val="between"/>
-        <c:majorUnit val="2"/>
+        <c:majorUnit val="1"/>
       </c:valAx>
       <c:spPr>
         <a:noFill/>
@@ -4562,9 +4310,9 @@
           </c:marker>
           <c:cat>
             <c:multiLvlStrRef>
-              <c:f>Sheet1!$A$2:$A$13</c:f>
+              <c:f>Sheet1!$A$2:$A$10</c:f>
               <c:multiLvlStrCache>
-                <c:ptCount val="12"/>
+                <c:ptCount val="9"/>
                 <c:lvl>
                   <c:pt idx="0">
                     <c:v>Jan</c:v>
@@ -4593,25 +4341,16 @@
                   <c:pt idx="8">
                     <c:v>Sep</c:v>
                   </c:pt>
-                  <c:pt idx="9">
-                    <c:v>Oct</c:v>
-                  </c:pt>
-                  <c:pt idx="10">
-                    <c:v>Nov</c:v>
-                  </c:pt>
-                  <c:pt idx="11">
-                    <c:v>Dec</c:v>
-                  </c:pt>
                 </c:lvl>
               </c:multiLvlStrCache>
             </c:multiLvlStrRef>
           </c:cat>
           <c:val>
             <c:numRef>
-              <c:f>Sheet1!$B$2:$B$13</c:f>
+              <c:f>Sheet1!$B$2:$B$10</c:f>
               <c:numCache>
                 <c:formatCode>General</c:formatCode>
-                <c:ptCount val="12"/>
+                <c:ptCount val="9"/>
                 <c:pt idx="0">
                   <c:v>13.47</c:v>
                 </c:pt>
@@ -4638,15 +4377,6 @@
                 </c:pt>
                 <c:pt idx="8">
                   <c:v>13.96</c:v>
-                </c:pt>
-                <c:pt idx="9">
-                  <c:v/>
-                </c:pt>
-                <c:pt idx="10">
-                  <c:v/>
-                </c:pt>
-                <c:pt idx="11">
-                  <c:v/>
                 </c:pt>
               </c:numCache>
             </c:numRef>
@@ -4726,8 +4456,8 @@
         <c:axId val="2094734552"/>
         <c:scaling>
           <c:orientation val="minMax"/>
-          <c:max val="18"/>
-          <c:min val="10"/>
+          <c:max val="16"/>
+          <c:min val="11"/>
         </c:scaling>
         <c:delete val="0"/>
         <c:axPos val="l"/>
@@ -4760,7 +4490,7 @@
         <c:crossAx val="2094734554"/>
         <c:crosses val="autoZero"/>
         <c:crossBetween val="between"/>
-        <c:majorUnit val="2"/>
+        <c:majorUnit val="1"/>
       </c:valAx>
       <c:spPr>
         <a:solidFill>
@@ -4872,9 +4602,9 @@
           </c:marker>
           <c:cat>
             <c:multiLvlStrRef>
-              <c:f>Sheet1!$A$2:$A$13</c:f>
+              <c:f>Sheet1!$A$2:$A$10</c:f>
               <c:multiLvlStrCache>
-                <c:ptCount val="12"/>
+                <c:ptCount val="9"/>
                 <c:lvl>
                   <c:pt idx="0">
                     <c:v>Jan</c:v>
@@ -4903,25 +4633,16 @@
                   <c:pt idx="8">
                     <c:v>Sep</c:v>
                   </c:pt>
-                  <c:pt idx="9">
-                    <c:v>Oct</c:v>
-                  </c:pt>
-                  <c:pt idx="10">
-                    <c:v>Nov</c:v>
-                  </c:pt>
-                  <c:pt idx="11">
-                    <c:v>Dec</c:v>
-                  </c:pt>
                 </c:lvl>
               </c:multiLvlStrCache>
             </c:multiLvlStrRef>
           </c:cat>
           <c:val>
             <c:numRef>
-              <c:f>Sheet1!$B$2:$B$13</c:f>
+              <c:f>Sheet1!$B$2:$B$10</c:f>
               <c:numCache>
                 <c:formatCode>General</c:formatCode>
-                <c:ptCount val="12"/>
+                <c:ptCount val="9"/>
                 <c:pt idx="0">
                   <c:v>13.41</c:v>
                 </c:pt>
@@ -4948,15 +4669,6 @@
                 </c:pt>
                 <c:pt idx="8">
                   <c:v>12.5</c:v>
-                </c:pt>
-                <c:pt idx="9">
-                  <c:v>13.74</c:v>
-                </c:pt>
-                <c:pt idx="10">
-                  <c:v>11.84</c:v>
-                </c:pt>
-                <c:pt idx="11">
-                  <c:v>12.92</c:v>
                 </c:pt>
               </c:numCache>
             </c:numRef>
@@ -5036,8 +4748,8 @@
         <c:axId val="2094734552"/>
         <c:scaling>
           <c:orientation val="minMax"/>
-          <c:max val="18"/>
-          <c:min val="10"/>
+          <c:max val="16"/>
+          <c:min val="11"/>
         </c:scaling>
         <c:delete val="0"/>
         <c:axPos val="l"/>
@@ -5070,7 +4782,7 @@
         <c:crossAx val="2094734554"/>
         <c:crosses val="autoZero"/>
         <c:crossBetween val="between"/>
-        <c:majorUnit val="2"/>
+        <c:majorUnit val="1"/>
       </c:valAx>
       <c:spPr>
         <a:solidFill>
@@ -5763,7 +5475,7 @@
           <a:p>
             <a:r>
               <a:rPr lang="en-US" dirty="0"/>
-              <a:t>Source: Qlik - Profit &amp; Loss. Same-store, INEOS excluded (opened 2026). Fixed ops = service + parts; GMC Prescott body shop gross excluded. Jan-Sep 2026 vs Jan-Sep 2025; 2025 shown January-December.</a:t>
+              <a:t>Source: Qlik - Profit &amp; Loss. Same-store, INEOS excluded (opened 2026). Fixed ops = service + parts; GMC Prescott body shop gross excluded. Jan-Sep 2026 vs Jan-Sep 2025.</a:t>
             </a:r>
             <a:endParaRPr lang="en-US" dirty="0"/>
           </a:p>
@@ -6115,7 +5827,7 @@
           <a:p>
             <a:r>
               <a:rPr lang="en-US" dirty="0"/>
-              <a:t>Source: Qlik - Profit &amp; Loss. Same-store, INEOS excluded (opened 2026). Fixed ops = service + parts; GMC Prescott body shop gross excluded. Jan-Sep 2026 vs Jan-Sep 2025; 2025 shown January-December.</a:t>
+              <a:t>Source: Qlik - Profit &amp; Loss. Same-store, INEOS excluded (opened 2026). Fixed ops = service + parts; GMC Prescott body shop gross excluded. Jan-Sep 2026 vs Jan-Sep 2025.</a:t>
             </a:r>
             <a:endParaRPr lang="en-US" dirty="0"/>
           </a:p>
@@ -6379,7 +6091,7 @@
           <a:p>
             <a:r>
               <a:rPr lang="en-US" dirty="0"/>
-              <a:t>Source: Qlik - Profit &amp; Loss. Same-store, INEOS excluded (opened 2026). Fixed ops = service + parts; GMC Prescott body shop gross excluded. Jan-Sep 2026 vs Jan-Sep 2025; 2025 shown January-December.</a:t>
+              <a:t>Source: Qlik - Profit &amp; Loss. Same-store, INEOS excluded (opened 2026). Fixed ops = service + parts; GMC Prescott body shop gross excluded. Jan-Sep 2026 vs Jan-Sep 2025.</a:t>
             </a:r>
             <a:endParaRPr lang="en-US" dirty="0"/>
           </a:p>

</xml_diff>

<commit_message>
Fixed ops gross: top/bottom-five slide replaces the who-moved-it chain
Co-Authored-By: Claude Opus 5.5 <noreply@anthropic.com>
Claude-Session: https://claude.ai/code/session_01Xa4nFVxuQGXmHARGph9WhS
</commit_message>
<xml_diff>
--- a/day2-deck/decks/Fixed Ops Gross - House Style.pptx
+++ b/day2-deck/decks/Fixed Ops Gross - House Style.pptx
@@ -6205,7 +6205,7 @@
           <a:p>
             <a:r>
               <a:rPr lang="en-US" dirty="0"/>
-              <a:t>Source: Qlik - Profit &amp; Loss. Same-store, INEOS excluded (opened 2026). Fixed ops = service + parts; GMC Prescott body shop gross excluded. Top five and bottom four stores by variance.</a:t>
+              <a:t>Source: Qlik - Profit &amp; Loss. Same-store, INEOS excluded (opened 2026). Fixed ops = service + parts; GMC Prescott body shop gross excluded. Top and bottom five stores by percent change in fixed ops gross, Jan-Sep 2026 vs 2025.Conversation starter: each top store says one thing they started doing; each bottom store says what got in the way and what they would try. The room trades ideas.</a:t>
             </a:r>
             <a:endParaRPr lang="en-US" dirty="0"/>
           </a:p>
@@ -33970,7 +33970,7 @@
         <p:spPr>
           <a:xfrm>
             <a:off x="457200" y="1207008"/>
-            <a:ext cx="5486400" cy="4782312"/>
+            <a:ext cx="11274552" cy="4782312"/>
           </a:xfrm>
           <a:prstGeom prst="rect">
             <a:avLst/>
@@ -33989,8 +33989,8 @@
         </p:nvSpPr>
         <p:spPr>
           <a:xfrm>
-            <a:off x="685800" y="1344168"/>
-            <a:ext cx="5029200" cy="292608"/>
+            <a:off x="713232" y="1298448"/>
+            <a:ext cx="10762488" cy="310896"/>
           </a:xfrm>
           <a:prstGeom prst="rect">
             <a:avLst/>
@@ -34006,17 +34006,17 @@
               <a:buNone/>
             </a:pPr>
             <a:r>
-              <a:rPr lang="en-US" sz="1500" dirty="0">
-                <a:solidFill>
-                  <a:srgbClr val="1A1A1A"/>
-                </a:solidFill>
-                <a:latin typeface="Inter" pitchFamily="34" charset="0"/>
-                <a:ea typeface="Inter" pitchFamily="34" charset="-122"/>
-                <a:cs typeface="Inter" pitchFamily="34" charset="-120"/>
-              </a:rPr>
-              <a:t>How the group got there, Jan–Sep</a:t>
-            </a:r>
-            <a:endParaRPr lang="en-US" sz="1500" dirty="0"/>
+              <a:rPr lang="en-US" sz="1400" dirty="0">
+                <a:solidFill>
+                  <a:srgbClr val="595959"/>
+                </a:solidFill>
+                <a:latin typeface="Inter" pitchFamily="34" charset="0"/>
+                <a:ea typeface="Inter" pitchFamily="34" charset="-122"/>
+                <a:cs typeface="Inter" pitchFamily="34" charset="-120"/>
+              </a:rPr>
+              <a:t>Jan–Sep 2026 against Jan–Sep 2025. Group $181.33M → $188.80M (+4.1%). Ranked by percent change.</a:t>
+            </a:r>
+            <a:endParaRPr lang="en-US" sz="1400" dirty="0"/>
           </a:p>
         </p:txBody>
       </p:sp>
@@ -34028,28 +34028,145 @@
         </p:nvSpPr>
         <p:spPr>
           <a:xfrm>
-            <a:off x="685800" y="1691640"/>
-            <a:ext cx="5029200" cy="10973"/>
+            <a:off x="658368" y="1737360"/>
+            <a:ext cx="5321808" cy="45720"/>
           </a:xfrm>
           <a:prstGeom prst="rect">
             <a:avLst/>
           </a:prstGeom>
           <a:solidFill>
-            <a:srgbClr val="1A1A1A"/>
+            <a:srgbClr val="12A566"/>
           </a:solidFill>
           <a:ln/>
         </p:spPr>
       </p:sp>
       <p:sp>
         <p:nvSpPr>
-          <p:cNvPr id="8" name="Shape 6"/>
+          <p:cNvPr id="8" name="Text 6"/>
+          <p:cNvSpPr txBox="1"/>
+          <p:nvPr/>
+        </p:nvSpPr>
+        <p:spPr>
+          <a:xfrm>
+            <a:off x="749808" y="1810512"/>
+            <a:ext cx="1828800" cy="274320"/>
+          </a:xfrm>
+          <a:prstGeom prst="rect">
+            <a:avLst/>
+          </a:prstGeom>
+          <a:noFill/>
+          <a:ln/>
+        </p:spPr>
+        <p:txBody>
+          <a:bodyPr wrap="square" lIns="0" tIns="0" rIns="0" bIns="0" rtlCol="0" anchor="ctr"/>
+          <a:lstStyle/>
+          <a:p>
+            <a:pPr indent="0" marL="0">
+              <a:buNone/>
+            </a:pPr>
+            <a:r>
+              <a:rPr lang="en-US" sz="1400" b="1" spc="100" kern="0" dirty="0">
+                <a:solidFill>
+                  <a:srgbClr val="0B7A4A"/>
+                </a:solidFill>
+                <a:latin typeface="Inter" pitchFamily="34" charset="0"/>
+                <a:ea typeface="Inter" pitchFamily="34" charset="-122"/>
+                <a:cs typeface="Inter" pitchFamily="34" charset="-120"/>
+              </a:rPr>
+              <a:t>TOP 5</a:t>
+            </a:r>
+            <a:endParaRPr lang="en-US" sz="1400" dirty="0"/>
+          </a:p>
+        </p:txBody>
+      </p:sp>
+      <p:sp>
+        <p:nvSpPr>
+          <p:cNvPr id="9" name="Text 7"/>
+          <p:cNvSpPr txBox="1"/>
+          <p:nvPr/>
+        </p:nvSpPr>
+        <p:spPr>
+          <a:xfrm>
+            <a:off x="2898648" y="1810512"/>
+            <a:ext cx="1828800" cy="274320"/>
+          </a:xfrm>
+          <a:prstGeom prst="rect">
+            <a:avLst/>
+          </a:prstGeom>
+          <a:noFill/>
+          <a:ln/>
+        </p:spPr>
+        <p:txBody>
+          <a:bodyPr wrap="square" lIns="0" tIns="0" rIns="0" bIns="0" rtlCol="0" anchor="ctr"/>
+          <a:lstStyle/>
+          <a:p>
+            <a:pPr indent="0" marL="0">
+              <a:buNone/>
+            </a:pPr>
+            <a:r>
+              <a:rPr lang="en-US" sz="1400" b="1" dirty="0">
+                <a:solidFill>
+                  <a:srgbClr val="595959"/>
+                </a:solidFill>
+                <a:latin typeface="Inter" pitchFamily="34" charset="0"/>
+                <a:ea typeface="Inter" pitchFamily="34" charset="-122"/>
+                <a:cs typeface="Inter" pitchFamily="34" charset="-120"/>
+              </a:rPr>
+              <a:t>2025 → 2026</a:t>
+            </a:r>
+            <a:endParaRPr lang="en-US" sz="1400" dirty="0"/>
+          </a:p>
+        </p:txBody>
+      </p:sp>
+      <p:sp>
+        <p:nvSpPr>
+          <p:cNvPr id="10" name="Text 8"/>
+          <p:cNvSpPr txBox="1"/>
+          <p:nvPr/>
+        </p:nvSpPr>
+        <p:spPr>
+          <a:xfrm>
+            <a:off x="4864608" y="1810512"/>
+            <a:ext cx="1051560" cy="274320"/>
+          </a:xfrm>
+          <a:prstGeom prst="rect">
+            <a:avLst/>
+          </a:prstGeom>
+          <a:noFill/>
+          <a:ln/>
+        </p:spPr>
+        <p:txBody>
+          <a:bodyPr wrap="square" lIns="0" tIns="0" rIns="0" bIns="0" rtlCol="0" anchor="ctr"/>
+          <a:lstStyle/>
+          <a:p>
+            <a:pPr algn="r" indent="0" marL="0">
+              <a:buNone/>
+            </a:pPr>
+            <a:r>
+              <a:rPr lang="en-US" sz="1400" b="1" dirty="0">
+                <a:solidFill>
+                  <a:srgbClr val="595959"/>
+                </a:solidFill>
+                <a:latin typeface="Inter" pitchFamily="34" charset="0"/>
+                <a:ea typeface="Inter" pitchFamily="34" charset="-122"/>
+                <a:cs typeface="Inter" pitchFamily="34" charset="-120"/>
+              </a:rPr>
+              <a:t>Change</a:t>
+            </a:r>
+            <a:endParaRPr lang="en-US" sz="1400" dirty="0"/>
+          </a:p>
+        </p:txBody>
+      </p:sp>
+      <p:sp>
+        <p:nvSpPr>
+          <p:cNvPr id="11" name="Shape 9"/>
           <p:cNvSpPr/>
           <p:nvPr/>
         </p:nvSpPr>
         <p:spPr>
           <a:xfrm>
-            <a:off x="713232" y="1700784"/>
-            <a:ext cx="4974336" cy="621792"/>
+            <a:off x="658368" y="2121408"/>
+            <a:ext cx="5321808" cy="751637"/>
           </a:xfrm>
           <a:prstGeom prst="rect">
             <a:avLst/>
@@ -34062,14 +34179,14 @@
       </p:sp>
       <p:sp>
         <p:nvSpPr>
-          <p:cNvPr id="9" name="Text 7"/>
-          <p:cNvSpPr txBox="1"/>
-          <p:nvPr/>
-        </p:nvSpPr>
-        <p:spPr>
-          <a:xfrm>
-            <a:off x="896112" y="1728216"/>
-            <a:ext cx="2743200" cy="457200"/>
+          <p:cNvPr id="12" name="Text 10"/>
+          <p:cNvSpPr txBox="1"/>
+          <p:nvPr/>
+        </p:nvSpPr>
+        <p:spPr>
+          <a:xfrm>
+            <a:off x="749808" y="2121408"/>
+            <a:ext cx="320040" cy="751637"/>
           </a:xfrm>
           <a:prstGeom prst="rect">
             <a:avLst/>
@@ -34085,7 +34202,46 @@
               <a:buNone/>
             </a:pPr>
             <a:r>
-              <a:rPr lang="en-US" sz="2600" b="1" dirty="0">
+              <a:rPr lang="en-US" sz="1500" b="1" dirty="0">
+                <a:solidFill>
+                  <a:srgbClr val="0B2C4A"/>
+                </a:solidFill>
+                <a:latin typeface="Inter" pitchFamily="34" charset="0"/>
+                <a:ea typeface="Inter" pitchFamily="34" charset="-122"/>
+                <a:cs typeface="Inter" pitchFamily="34" charset="-120"/>
+              </a:rPr>
+              <a:t>1</a:t>
+            </a:r>
+            <a:endParaRPr lang="en-US" sz="1500" dirty="0"/>
+          </a:p>
+        </p:txBody>
+      </p:sp>
+      <p:sp>
+        <p:nvSpPr>
+          <p:cNvPr id="13" name="Text 11"/>
+          <p:cNvSpPr txBox="1"/>
+          <p:nvPr/>
+        </p:nvSpPr>
+        <p:spPr>
+          <a:xfrm>
+            <a:off x="1115568" y="2121408"/>
+            <a:ext cx="1737360" cy="751637"/>
+          </a:xfrm>
+          <a:prstGeom prst="rect">
+            <a:avLst/>
+          </a:prstGeom>
+          <a:noFill/>
+          <a:ln/>
+        </p:spPr>
+        <p:txBody>
+          <a:bodyPr wrap="square" lIns="0" tIns="0" rIns="0" bIns="0" rtlCol="0" anchor="ctr"/>
+          <a:lstStyle/>
+          <a:p>
+            <a:pPr indent="0" marL="0">
+              <a:buNone/>
+            </a:pPr>
+            <a:r>
+              <a:rPr lang="en-US" sz="1400" b="1" dirty="0">
                 <a:solidFill>
                   <a:srgbClr val="1A1A1A"/>
                 </a:solidFill>
@@ -34093,34 +34249,34 @@
                 <a:ea typeface="Inter" pitchFamily="34" charset="-122"/>
                 <a:cs typeface="Inter" pitchFamily="34" charset="-120"/>
               </a:rPr>
-              <a:t>$181.33M</a:t>
-            </a:r>
-            <a:endParaRPr lang="en-US" sz="2600" dirty="0"/>
-          </a:p>
-        </p:txBody>
-      </p:sp>
-      <p:sp>
-        <p:nvSpPr>
-          <p:cNvPr id="10" name="Text 8"/>
-          <p:cNvSpPr txBox="1"/>
-          <p:nvPr/>
-        </p:nvSpPr>
-        <p:spPr>
-          <a:xfrm>
-            <a:off x="3657600" y="1728216"/>
-            <a:ext cx="1874520" cy="585216"/>
-          </a:xfrm>
-          <a:prstGeom prst="rect">
-            <a:avLst/>
-          </a:prstGeom>
-          <a:noFill/>
-          <a:ln/>
-        </p:spPr>
-        <p:txBody>
-          <a:bodyPr wrap="square" lIns="0" tIns="0" rIns="0" bIns="0" rtlCol="0" anchor="ctr"/>
-          <a:lstStyle/>
-          <a:p>
-            <a:pPr algn="r" indent="0" marL="0">
+              <a:t>Hyundai Prescott</a:t>
+            </a:r>
+            <a:endParaRPr lang="en-US" sz="1400" dirty="0"/>
+          </a:p>
+        </p:txBody>
+      </p:sp>
+      <p:sp>
+        <p:nvSpPr>
+          <p:cNvPr id="14" name="Text 12"/>
+          <p:cNvSpPr txBox="1"/>
+          <p:nvPr/>
+        </p:nvSpPr>
+        <p:spPr>
+          <a:xfrm>
+            <a:off x="2898648" y="2121408"/>
+            <a:ext cx="1920240" cy="751637"/>
+          </a:xfrm>
+          <a:prstGeom prst="rect">
+            <a:avLst/>
+          </a:prstGeom>
+          <a:noFill/>
+          <a:ln/>
+        </p:spPr>
+        <p:txBody>
+          <a:bodyPr wrap="square" lIns="0" tIns="0" rIns="0" bIns="0" rtlCol="0" anchor="ctr"/>
+          <a:lstStyle/>
+          <a:p>
+            <a:pPr indent="0" marL="0">
               <a:buNone/>
             </a:pPr>
             <a:r>
@@ -34132,7 +34288,35 @@
                 <a:ea typeface="Inter" pitchFamily="34" charset="-122"/>
                 <a:cs typeface="Inter" pitchFamily="34" charset="-120"/>
               </a:rPr>
-              <a:t>2025 group</a:t>
+              <a:t>$1.13M  </a:t>
+            </a:r>
+            <a:pPr indent="0" marL="0">
+              <a:buNone/>
+            </a:pPr>
+            <a:r>
+              <a:rPr lang="en-US" sz="1400" b="1" dirty="0">
+                <a:solidFill>
+                  <a:srgbClr val="0B7A4A"/>
+                </a:solidFill>
+                <a:latin typeface="Inter" pitchFamily="34" charset="0"/>
+                <a:ea typeface="Inter" pitchFamily="34" charset="-122"/>
+                <a:cs typeface="Inter" pitchFamily="34" charset="-120"/>
+              </a:rPr>
+              <a:t>→  </a:t>
+            </a:r>
+            <a:pPr indent="0" marL="0">
+              <a:buNone/>
+            </a:pPr>
+            <a:r>
+              <a:rPr lang="en-US" sz="1400" b="1" dirty="0">
+                <a:solidFill>
+                  <a:srgbClr val="0B7A4A"/>
+                </a:solidFill>
+                <a:latin typeface="Inter" pitchFamily="34" charset="0"/>
+                <a:ea typeface="Inter" pitchFamily="34" charset="-122"/>
+                <a:cs typeface="Inter" pitchFamily="34" charset="-120"/>
+              </a:rPr>
+              <a:t>$1.54M</a:t>
             </a:r>
             <a:endParaRPr lang="en-US" sz="1400" dirty="0"/>
           </a:p>
@@ -34140,93 +34324,645 @@
       </p:sp>
       <p:sp>
         <p:nvSpPr>
-          <p:cNvPr id="11" name="Shape 9"/>
+          <p:cNvPr id="15" name="Text 13"/>
+          <p:cNvSpPr txBox="1"/>
+          <p:nvPr/>
+        </p:nvSpPr>
+        <p:spPr>
+          <a:xfrm>
+            <a:off x="4864608" y="2121408"/>
+            <a:ext cx="1051560" cy="751637"/>
+          </a:xfrm>
+          <a:prstGeom prst="rect">
+            <a:avLst/>
+          </a:prstGeom>
+          <a:noFill/>
+          <a:ln/>
+        </p:spPr>
+        <p:txBody>
+          <a:bodyPr wrap="square" lIns="0" tIns="0" rIns="0" bIns="0" rtlCol="0" anchor="ctr"/>
+          <a:lstStyle/>
+          <a:p>
+            <a:pPr algn="r" indent="0" marL="0">
+              <a:buNone/>
+            </a:pPr>
+            <a:r>
+              <a:rPr lang="en-US" sz="1600" b="1" dirty="0">
+                <a:solidFill>
+                  <a:srgbClr val="0B7A4A"/>
+                </a:solidFill>
+                <a:latin typeface="Inter" pitchFamily="34" charset="0"/>
+                <a:ea typeface="Inter" pitchFamily="34" charset="-122"/>
+                <a:cs typeface="Inter" pitchFamily="34" charset="-120"/>
+              </a:rPr>
+              <a:t>+35.8%</a:t>
+            </a:r>
+            <a:endParaRPr lang="en-US" sz="1600" dirty="0"/>
+          </a:p>
+        </p:txBody>
+      </p:sp>
+      <p:sp>
+        <p:nvSpPr>
+          <p:cNvPr id="16" name="Text 14"/>
+          <p:cNvSpPr txBox="1"/>
+          <p:nvPr/>
+        </p:nvSpPr>
+        <p:spPr>
+          <a:xfrm>
+            <a:off x="749808" y="2873045"/>
+            <a:ext cx="320040" cy="751637"/>
+          </a:xfrm>
+          <a:prstGeom prst="rect">
+            <a:avLst/>
+          </a:prstGeom>
+          <a:noFill/>
+          <a:ln/>
+        </p:spPr>
+        <p:txBody>
+          <a:bodyPr wrap="square" lIns="0" tIns="0" rIns="0" bIns="0" rtlCol="0" anchor="ctr"/>
+          <a:lstStyle/>
+          <a:p>
+            <a:pPr indent="0" marL="0">
+              <a:buNone/>
+            </a:pPr>
+            <a:r>
+              <a:rPr lang="en-US" sz="1500" b="1" dirty="0">
+                <a:solidFill>
+                  <a:srgbClr val="0B2C4A"/>
+                </a:solidFill>
+                <a:latin typeface="Inter" pitchFamily="34" charset="0"/>
+                <a:ea typeface="Inter" pitchFamily="34" charset="-122"/>
+                <a:cs typeface="Inter" pitchFamily="34" charset="-120"/>
+              </a:rPr>
+              <a:t>2</a:t>
+            </a:r>
+            <a:endParaRPr lang="en-US" sz="1500" dirty="0"/>
+          </a:p>
+        </p:txBody>
+      </p:sp>
+      <p:sp>
+        <p:nvSpPr>
+          <p:cNvPr id="17" name="Text 15"/>
+          <p:cNvSpPr txBox="1"/>
+          <p:nvPr/>
+        </p:nvSpPr>
+        <p:spPr>
+          <a:xfrm>
+            <a:off x="1115568" y="2873045"/>
+            <a:ext cx="1737360" cy="751637"/>
+          </a:xfrm>
+          <a:prstGeom prst="rect">
+            <a:avLst/>
+          </a:prstGeom>
+          <a:noFill/>
+          <a:ln/>
+        </p:spPr>
+        <p:txBody>
+          <a:bodyPr wrap="square" lIns="0" tIns="0" rIns="0" bIns="0" rtlCol="0" anchor="ctr"/>
+          <a:lstStyle/>
+          <a:p>
+            <a:pPr indent="0" marL="0">
+              <a:buNone/>
+            </a:pPr>
+            <a:r>
+              <a:rPr lang="en-US" sz="1400" b="1" dirty="0">
+                <a:solidFill>
+                  <a:srgbClr val="1A1A1A"/>
+                </a:solidFill>
+                <a:latin typeface="Inter" pitchFamily="34" charset="0"/>
+                <a:ea typeface="Inter" pitchFamily="34" charset="-122"/>
+                <a:cs typeface="Inter" pitchFamily="34" charset="-120"/>
+              </a:rPr>
+              <a:t>Lincoln</a:t>
+            </a:r>
+            <a:endParaRPr lang="en-US" sz="1400" dirty="0"/>
+          </a:p>
+        </p:txBody>
+      </p:sp>
+      <p:sp>
+        <p:nvSpPr>
+          <p:cNvPr id="18" name="Text 16"/>
+          <p:cNvSpPr txBox="1"/>
+          <p:nvPr/>
+        </p:nvSpPr>
+        <p:spPr>
+          <a:xfrm>
+            <a:off x="2898648" y="2873045"/>
+            <a:ext cx="1920240" cy="751637"/>
+          </a:xfrm>
+          <a:prstGeom prst="rect">
+            <a:avLst/>
+          </a:prstGeom>
+          <a:noFill/>
+          <a:ln/>
+        </p:spPr>
+        <p:txBody>
+          <a:bodyPr wrap="square" lIns="0" tIns="0" rIns="0" bIns="0" rtlCol="0" anchor="ctr"/>
+          <a:lstStyle/>
+          <a:p>
+            <a:pPr indent="0" marL="0">
+              <a:buNone/>
+            </a:pPr>
+            <a:r>
+              <a:rPr lang="en-US" sz="1400" dirty="0">
+                <a:solidFill>
+                  <a:srgbClr val="595959"/>
+                </a:solidFill>
+                <a:latin typeface="Inter" pitchFamily="34" charset="0"/>
+                <a:ea typeface="Inter" pitchFamily="34" charset="-122"/>
+                <a:cs typeface="Inter" pitchFamily="34" charset="-120"/>
+              </a:rPr>
+              <a:t>$2.26M  </a:t>
+            </a:r>
+            <a:pPr indent="0" marL="0">
+              <a:buNone/>
+            </a:pPr>
+            <a:r>
+              <a:rPr lang="en-US" sz="1400" b="1" dirty="0">
+                <a:solidFill>
+                  <a:srgbClr val="0B7A4A"/>
+                </a:solidFill>
+                <a:latin typeface="Inter" pitchFamily="34" charset="0"/>
+                <a:ea typeface="Inter" pitchFamily="34" charset="-122"/>
+                <a:cs typeface="Inter" pitchFamily="34" charset="-120"/>
+              </a:rPr>
+              <a:t>→  </a:t>
+            </a:r>
+            <a:pPr indent="0" marL="0">
+              <a:buNone/>
+            </a:pPr>
+            <a:r>
+              <a:rPr lang="en-US" sz="1400" b="1" dirty="0">
+                <a:solidFill>
+                  <a:srgbClr val="0B7A4A"/>
+                </a:solidFill>
+                <a:latin typeface="Inter" pitchFamily="34" charset="0"/>
+                <a:ea typeface="Inter" pitchFamily="34" charset="-122"/>
+                <a:cs typeface="Inter" pitchFamily="34" charset="-120"/>
+              </a:rPr>
+              <a:t>$2.98M</a:t>
+            </a:r>
+            <a:endParaRPr lang="en-US" sz="1400" dirty="0"/>
+          </a:p>
+        </p:txBody>
+      </p:sp>
+      <p:sp>
+        <p:nvSpPr>
+          <p:cNvPr id="19" name="Text 17"/>
+          <p:cNvSpPr txBox="1"/>
+          <p:nvPr/>
+        </p:nvSpPr>
+        <p:spPr>
+          <a:xfrm>
+            <a:off x="4864608" y="2873045"/>
+            <a:ext cx="1051560" cy="751637"/>
+          </a:xfrm>
+          <a:prstGeom prst="rect">
+            <a:avLst/>
+          </a:prstGeom>
+          <a:noFill/>
+          <a:ln/>
+        </p:spPr>
+        <p:txBody>
+          <a:bodyPr wrap="square" lIns="0" tIns="0" rIns="0" bIns="0" rtlCol="0" anchor="ctr"/>
+          <a:lstStyle/>
+          <a:p>
+            <a:pPr algn="r" indent="0" marL="0">
+              <a:buNone/>
+            </a:pPr>
+            <a:r>
+              <a:rPr lang="en-US" sz="1600" b="1" dirty="0">
+                <a:solidFill>
+                  <a:srgbClr val="0B7A4A"/>
+                </a:solidFill>
+                <a:latin typeface="Inter" pitchFamily="34" charset="0"/>
+                <a:ea typeface="Inter" pitchFamily="34" charset="-122"/>
+                <a:cs typeface="Inter" pitchFamily="34" charset="-120"/>
+              </a:rPr>
+              <a:t>+31.7%</a:t>
+            </a:r>
+            <a:endParaRPr lang="en-US" sz="1600" dirty="0"/>
+          </a:p>
+        </p:txBody>
+      </p:sp>
+      <p:sp>
+        <p:nvSpPr>
+          <p:cNvPr id="20" name="Shape 18"/>
           <p:cNvSpPr/>
           <p:nvPr/>
         </p:nvSpPr>
         <p:spPr>
           <a:xfrm>
-            <a:off x="987552" y="2395728"/>
-            <a:ext cx="292608" cy="292608"/>
-          </a:xfrm>
-          <a:prstGeom prst="ellipse">
+            <a:off x="658368" y="3624682"/>
+            <a:ext cx="5321808" cy="751637"/>
+          </a:xfrm>
+          <a:prstGeom prst="rect">
             <a:avLst/>
           </a:prstGeom>
           <a:solidFill>
-            <a:srgbClr val="2587C5"/>
+            <a:srgbClr val="F7F7F7"/>
           </a:solidFill>
           <a:ln/>
         </p:spPr>
       </p:sp>
       <p:sp>
         <p:nvSpPr>
-          <p:cNvPr id="12" name="Text 10"/>
-          <p:cNvSpPr txBox="1"/>
-          <p:nvPr/>
-        </p:nvSpPr>
-        <p:spPr>
-          <a:xfrm>
-            <a:off x="987552" y="2395728"/>
-            <a:ext cx="292608" cy="292608"/>
-          </a:xfrm>
-          <a:prstGeom prst="rect">
-            <a:avLst/>
-          </a:prstGeom>
-          <a:noFill/>
-          <a:ln/>
-        </p:spPr>
-        <p:txBody>
-          <a:bodyPr wrap="square" lIns="0" tIns="0" rIns="0" bIns="0" rtlCol="0" anchor="ctr"/>
-          <a:lstStyle/>
-          <a:p>
-            <a:pPr algn="ctr" indent="0" marL="0">
-              <a:buNone/>
-            </a:pPr>
-            <a:r>
-              <a:rPr lang="en-US" sz="1800" b="1" dirty="0">
-                <a:solidFill>
-                  <a:srgbClr val="FFFFFF"/>
-                </a:solidFill>
-                <a:latin typeface="Inter" pitchFamily="34" charset="0"/>
-                <a:ea typeface="Inter" pitchFamily="34" charset="-122"/>
-                <a:cs typeface="Inter" pitchFamily="34" charset="-120"/>
-              </a:rPr>
-              <a:t>+</a:t>
-            </a:r>
-            <a:endParaRPr lang="en-US" sz="1800" dirty="0"/>
-          </a:p>
-        </p:txBody>
-      </p:sp>
-      <p:sp>
-        <p:nvSpPr>
-          <p:cNvPr id="13" name="Shape 11"/>
+          <p:cNvPr id="21" name="Text 19"/>
+          <p:cNvSpPr txBox="1"/>
+          <p:nvPr/>
+        </p:nvSpPr>
+        <p:spPr>
+          <a:xfrm>
+            <a:off x="749808" y="3624682"/>
+            <a:ext cx="320040" cy="751637"/>
+          </a:xfrm>
+          <a:prstGeom prst="rect">
+            <a:avLst/>
+          </a:prstGeom>
+          <a:noFill/>
+          <a:ln/>
+        </p:spPr>
+        <p:txBody>
+          <a:bodyPr wrap="square" lIns="0" tIns="0" rIns="0" bIns="0" rtlCol="0" anchor="ctr"/>
+          <a:lstStyle/>
+          <a:p>
+            <a:pPr indent="0" marL="0">
+              <a:buNone/>
+            </a:pPr>
+            <a:r>
+              <a:rPr lang="en-US" sz="1500" b="1" dirty="0">
+                <a:solidFill>
+                  <a:srgbClr val="0B2C4A"/>
+                </a:solidFill>
+                <a:latin typeface="Inter" pitchFamily="34" charset="0"/>
+                <a:ea typeface="Inter" pitchFamily="34" charset="-122"/>
+                <a:cs typeface="Inter" pitchFamily="34" charset="-120"/>
+              </a:rPr>
+              <a:t>3</a:t>
+            </a:r>
+            <a:endParaRPr lang="en-US" sz="1500" dirty="0"/>
+          </a:p>
+        </p:txBody>
+      </p:sp>
+      <p:sp>
+        <p:nvSpPr>
+          <p:cNvPr id="22" name="Text 20"/>
+          <p:cNvSpPr txBox="1"/>
+          <p:nvPr/>
+        </p:nvSpPr>
+        <p:spPr>
+          <a:xfrm>
+            <a:off x="1115568" y="3624682"/>
+            <a:ext cx="1737360" cy="751637"/>
+          </a:xfrm>
+          <a:prstGeom prst="rect">
+            <a:avLst/>
+          </a:prstGeom>
+          <a:noFill/>
+          <a:ln/>
+        </p:spPr>
+        <p:txBody>
+          <a:bodyPr wrap="square" lIns="0" tIns="0" rIns="0" bIns="0" rtlCol="0" anchor="ctr"/>
+          <a:lstStyle/>
+          <a:p>
+            <a:pPr indent="0" marL="0">
+              <a:buNone/>
+            </a:pPr>
+            <a:r>
+              <a:rPr lang="en-US" sz="1400" b="1" dirty="0">
+                <a:solidFill>
+                  <a:srgbClr val="1A1A1A"/>
+                </a:solidFill>
+                <a:latin typeface="Inter" pitchFamily="34" charset="0"/>
+                <a:ea typeface="Inter" pitchFamily="34" charset="-122"/>
+                <a:cs typeface="Inter" pitchFamily="34" charset="-120"/>
+              </a:rPr>
+              <a:t>Lexus</a:t>
+            </a:r>
+            <a:endParaRPr lang="en-US" sz="1400" dirty="0"/>
+          </a:p>
+        </p:txBody>
+      </p:sp>
+      <p:sp>
+        <p:nvSpPr>
+          <p:cNvPr id="23" name="Text 21"/>
+          <p:cNvSpPr txBox="1"/>
+          <p:nvPr/>
+        </p:nvSpPr>
+        <p:spPr>
+          <a:xfrm>
+            <a:off x="2898648" y="3624682"/>
+            <a:ext cx="1920240" cy="751637"/>
+          </a:xfrm>
+          <a:prstGeom prst="rect">
+            <a:avLst/>
+          </a:prstGeom>
+          <a:noFill/>
+          <a:ln/>
+        </p:spPr>
+        <p:txBody>
+          <a:bodyPr wrap="square" lIns="0" tIns="0" rIns="0" bIns="0" rtlCol="0" anchor="ctr"/>
+          <a:lstStyle/>
+          <a:p>
+            <a:pPr indent="0" marL="0">
+              <a:buNone/>
+            </a:pPr>
+            <a:r>
+              <a:rPr lang="en-US" sz="1400" dirty="0">
+                <a:solidFill>
+                  <a:srgbClr val="595959"/>
+                </a:solidFill>
+                <a:latin typeface="Inter" pitchFamily="34" charset="0"/>
+                <a:ea typeface="Inter" pitchFamily="34" charset="-122"/>
+                <a:cs typeface="Inter" pitchFamily="34" charset="-120"/>
+              </a:rPr>
+              <a:t>$3.38M  </a:t>
+            </a:r>
+            <a:pPr indent="0" marL="0">
+              <a:buNone/>
+            </a:pPr>
+            <a:r>
+              <a:rPr lang="en-US" sz="1400" b="1" dirty="0">
+                <a:solidFill>
+                  <a:srgbClr val="0B7A4A"/>
+                </a:solidFill>
+                <a:latin typeface="Inter" pitchFamily="34" charset="0"/>
+                <a:ea typeface="Inter" pitchFamily="34" charset="-122"/>
+                <a:cs typeface="Inter" pitchFamily="34" charset="-120"/>
+              </a:rPr>
+              <a:t>→  </a:t>
+            </a:r>
+            <a:pPr indent="0" marL="0">
+              <a:buNone/>
+            </a:pPr>
+            <a:r>
+              <a:rPr lang="en-US" sz="1400" b="1" dirty="0">
+                <a:solidFill>
+                  <a:srgbClr val="0B7A4A"/>
+                </a:solidFill>
+                <a:latin typeface="Inter" pitchFamily="34" charset="0"/>
+                <a:ea typeface="Inter" pitchFamily="34" charset="-122"/>
+                <a:cs typeface="Inter" pitchFamily="34" charset="-120"/>
+              </a:rPr>
+              <a:t>$4.15M</a:t>
+            </a:r>
+            <a:endParaRPr lang="en-US" sz="1400" dirty="0"/>
+          </a:p>
+        </p:txBody>
+      </p:sp>
+      <p:sp>
+        <p:nvSpPr>
+          <p:cNvPr id="24" name="Text 22"/>
+          <p:cNvSpPr txBox="1"/>
+          <p:nvPr/>
+        </p:nvSpPr>
+        <p:spPr>
+          <a:xfrm>
+            <a:off x="4864608" y="3624682"/>
+            <a:ext cx="1051560" cy="751637"/>
+          </a:xfrm>
+          <a:prstGeom prst="rect">
+            <a:avLst/>
+          </a:prstGeom>
+          <a:noFill/>
+          <a:ln/>
+        </p:spPr>
+        <p:txBody>
+          <a:bodyPr wrap="square" lIns="0" tIns="0" rIns="0" bIns="0" rtlCol="0" anchor="ctr"/>
+          <a:lstStyle/>
+          <a:p>
+            <a:pPr algn="r" indent="0" marL="0">
+              <a:buNone/>
+            </a:pPr>
+            <a:r>
+              <a:rPr lang="en-US" sz="1600" b="1" dirty="0">
+                <a:solidFill>
+                  <a:srgbClr val="0B7A4A"/>
+                </a:solidFill>
+                <a:latin typeface="Inter" pitchFamily="34" charset="0"/>
+                <a:ea typeface="Inter" pitchFamily="34" charset="-122"/>
+                <a:cs typeface="Inter" pitchFamily="34" charset="-120"/>
+              </a:rPr>
+              <a:t>+22.6%</a:t>
+            </a:r>
+            <a:endParaRPr lang="en-US" sz="1600" dirty="0"/>
+          </a:p>
+        </p:txBody>
+      </p:sp>
+      <p:sp>
+        <p:nvSpPr>
+          <p:cNvPr id="25" name="Text 23"/>
+          <p:cNvSpPr txBox="1"/>
+          <p:nvPr/>
+        </p:nvSpPr>
+        <p:spPr>
+          <a:xfrm>
+            <a:off x="749808" y="4376318"/>
+            <a:ext cx="320040" cy="751637"/>
+          </a:xfrm>
+          <a:prstGeom prst="rect">
+            <a:avLst/>
+          </a:prstGeom>
+          <a:noFill/>
+          <a:ln/>
+        </p:spPr>
+        <p:txBody>
+          <a:bodyPr wrap="square" lIns="0" tIns="0" rIns="0" bIns="0" rtlCol="0" anchor="ctr"/>
+          <a:lstStyle/>
+          <a:p>
+            <a:pPr indent="0" marL="0">
+              <a:buNone/>
+            </a:pPr>
+            <a:r>
+              <a:rPr lang="en-US" sz="1500" b="1" dirty="0">
+                <a:solidFill>
+                  <a:srgbClr val="0B2C4A"/>
+                </a:solidFill>
+                <a:latin typeface="Inter" pitchFamily="34" charset="0"/>
+                <a:ea typeface="Inter" pitchFamily="34" charset="-122"/>
+                <a:cs typeface="Inter" pitchFamily="34" charset="-120"/>
+              </a:rPr>
+              <a:t>4</a:t>
+            </a:r>
+            <a:endParaRPr lang="en-US" sz="1500" dirty="0"/>
+          </a:p>
+        </p:txBody>
+      </p:sp>
+      <p:sp>
+        <p:nvSpPr>
+          <p:cNvPr id="26" name="Text 24"/>
+          <p:cNvSpPr txBox="1"/>
+          <p:nvPr/>
+        </p:nvSpPr>
+        <p:spPr>
+          <a:xfrm>
+            <a:off x="1115568" y="4376318"/>
+            <a:ext cx="1737360" cy="751637"/>
+          </a:xfrm>
+          <a:prstGeom prst="rect">
+            <a:avLst/>
+          </a:prstGeom>
+          <a:noFill/>
+          <a:ln/>
+        </p:spPr>
+        <p:txBody>
+          <a:bodyPr wrap="square" lIns="0" tIns="0" rIns="0" bIns="0" rtlCol="0" anchor="ctr"/>
+          <a:lstStyle/>
+          <a:p>
+            <a:pPr indent="0" marL="0">
+              <a:buNone/>
+            </a:pPr>
+            <a:r>
+              <a:rPr lang="en-US" sz="1400" b="1" dirty="0">
+                <a:solidFill>
+                  <a:srgbClr val="1A1A1A"/>
+                </a:solidFill>
+                <a:latin typeface="Inter" pitchFamily="34" charset="0"/>
+                <a:ea typeface="Inter" pitchFamily="34" charset="-122"/>
+                <a:cs typeface="Inter" pitchFamily="34" charset="-120"/>
+              </a:rPr>
+              <a:t>Audi Henderson</a:t>
+            </a:r>
+            <a:endParaRPr lang="en-US" sz="1400" dirty="0"/>
+          </a:p>
+        </p:txBody>
+      </p:sp>
+      <p:sp>
+        <p:nvSpPr>
+          <p:cNvPr id="27" name="Text 25"/>
+          <p:cNvSpPr txBox="1"/>
+          <p:nvPr/>
+        </p:nvSpPr>
+        <p:spPr>
+          <a:xfrm>
+            <a:off x="2898648" y="4376318"/>
+            <a:ext cx="1920240" cy="751637"/>
+          </a:xfrm>
+          <a:prstGeom prst="rect">
+            <a:avLst/>
+          </a:prstGeom>
+          <a:noFill/>
+          <a:ln/>
+        </p:spPr>
+        <p:txBody>
+          <a:bodyPr wrap="square" lIns="0" tIns="0" rIns="0" bIns="0" rtlCol="0" anchor="ctr"/>
+          <a:lstStyle/>
+          <a:p>
+            <a:pPr indent="0" marL="0">
+              <a:buNone/>
+            </a:pPr>
+            <a:r>
+              <a:rPr lang="en-US" sz="1400" dirty="0">
+                <a:solidFill>
+                  <a:srgbClr val="595959"/>
+                </a:solidFill>
+                <a:latin typeface="Inter" pitchFamily="34" charset="0"/>
+                <a:ea typeface="Inter" pitchFamily="34" charset="-122"/>
+                <a:cs typeface="Inter" pitchFamily="34" charset="-120"/>
+              </a:rPr>
+              <a:t>$10.64M  </a:t>
+            </a:r>
+            <a:pPr indent="0" marL="0">
+              <a:buNone/>
+            </a:pPr>
+            <a:r>
+              <a:rPr lang="en-US" sz="1400" b="1" dirty="0">
+                <a:solidFill>
+                  <a:srgbClr val="0B7A4A"/>
+                </a:solidFill>
+                <a:latin typeface="Inter" pitchFamily="34" charset="0"/>
+                <a:ea typeface="Inter" pitchFamily="34" charset="-122"/>
+                <a:cs typeface="Inter" pitchFamily="34" charset="-120"/>
+              </a:rPr>
+              <a:t>→  </a:t>
+            </a:r>
+            <a:pPr indent="0" marL="0">
+              <a:buNone/>
+            </a:pPr>
+            <a:r>
+              <a:rPr lang="en-US" sz="1400" b="1" dirty="0">
+                <a:solidFill>
+                  <a:srgbClr val="0B7A4A"/>
+                </a:solidFill>
+                <a:latin typeface="Inter" pitchFamily="34" charset="0"/>
+                <a:ea typeface="Inter" pitchFamily="34" charset="-122"/>
+                <a:cs typeface="Inter" pitchFamily="34" charset="-120"/>
+              </a:rPr>
+              <a:t>$12.34M</a:t>
+            </a:r>
+            <a:endParaRPr lang="en-US" sz="1400" dirty="0"/>
+          </a:p>
+        </p:txBody>
+      </p:sp>
+      <p:sp>
+        <p:nvSpPr>
+          <p:cNvPr id="28" name="Text 26"/>
+          <p:cNvSpPr txBox="1"/>
+          <p:nvPr/>
+        </p:nvSpPr>
+        <p:spPr>
+          <a:xfrm>
+            <a:off x="4864608" y="4376318"/>
+            <a:ext cx="1051560" cy="751637"/>
+          </a:xfrm>
+          <a:prstGeom prst="rect">
+            <a:avLst/>
+          </a:prstGeom>
+          <a:noFill/>
+          <a:ln/>
+        </p:spPr>
+        <p:txBody>
+          <a:bodyPr wrap="square" lIns="0" tIns="0" rIns="0" bIns="0" rtlCol="0" anchor="ctr"/>
+          <a:lstStyle/>
+          <a:p>
+            <a:pPr algn="r" indent="0" marL="0">
+              <a:buNone/>
+            </a:pPr>
+            <a:r>
+              <a:rPr lang="en-US" sz="1600" b="1" dirty="0">
+                <a:solidFill>
+                  <a:srgbClr val="0B7A4A"/>
+                </a:solidFill>
+                <a:latin typeface="Inter" pitchFamily="34" charset="0"/>
+                <a:ea typeface="Inter" pitchFamily="34" charset="-122"/>
+                <a:cs typeface="Inter" pitchFamily="34" charset="-120"/>
+              </a:rPr>
+              <a:t>+16.0%</a:t>
+            </a:r>
+            <a:endParaRPr lang="en-US" sz="1600" dirty="0"/>
+          </a:p>
+        </p:txBody>
+      </p:sp>
+      <p:sp>
+        <p:nvSpPr>
+          <p:cNvPr id="29" name="Shape 27"/>
           <p:cNvSpPr/>
           <p:nvPr/>
         </p:nvSpPr>
         <p:spPr>
           <a:xfrm>
-            <a:off x="713232" y="2706624"/>
-            <a:ext cx="4974336" cy="621792"/>
+            <a:off x="658368" y="5127955"/>
+            <a:ext cx="5321808" cy="751637"/>
           </a:xfrm>
           <a:prstGeom prst="rect">
             <a:avLst/>
           </a:prstGeom>
           <a:solidFill>
-            <a:srgbClr val="E6F6EE"/>
+            <a:srgbClr val="F7F7F7"/>
           </a:solidFill>
           <a:ln/>
         </p:spPr>
       </p:sp>
       <p:sp>
         <p:nvSpPr>
-          <p:cNvPr id="14" name="Text 12"/>
-          <p:cNvSpPr txBox="1"/>
-          <p:nvPr/>
-        </p:nvSpPr>
-        <p:spPr>
-          <a:xfrm>
-            <a:off x="896112" y="2734056"/>
-            <a:ext cx="2743200" cy="457200"/>
+          <p:cNvPr id="30" name="Text 28"/>
+          <p:cNvSpPr txBox="1"/>
+          <p:nvPr/>
+        </p:nvSpPr>
+        <p:spPr>
+          <a:xfrm>
+            <a:off x="749808" y="5127955"/>
+            <a:ext cx="320040" cy="751637"/>
           </a:xfrm>
           <a:prstGeom prst="rect">
             <a:avLst/>
@@ -34242,7 +34978,99 @@
               <a:buNone/>
             </a:pPr>
             <a:r>
-              <a:rPr lang="en-US" sz="2600" b="1" dirty="0">
+              <a:rPr lang="en-US" sz="1500" b="1" dirty="0">
+                <a:solidFill>
+                  <a:srgbClr val="0B2C4A"/>
+                </a:solidFill>
+                <a:latin typeface="Inter" pitchFamily="34" charset="0"/>
+                <a:ea typeface="Inter" pitchFamily="34" charset="-122"/>
+                <a:cs typeface="Inter" pitchFamily="34" charset="-120"/>
+              </a:rPr>
+              <a:t>5</a:t>
+            </a:r>
+            <a:endParaRPr lang="en-US" sz="1500" dirty="0"/>
+          </a:p>
+        </p:txBody>
+      </p:sp>
+      <p:sp>
+        <p:nvSpPr>
+          <p:cNvPr id="31" name="Text 29"/>
+          <p:cNvSpPr txBox="1"/>
+          <p:nvPr/>
+        </p:nvSpPr>
+        <p:spPr>
+          <a:xfrm>
+            <a:off x="1115568" y="5127955"/>
+            <a:ext cx="1737360" cy="751637"/>
+          </a:xfrm>
+          <a:prstGeom prst="rect">
+            <a:avLst/>
+          </a:prstGeom>
+          <a:noFill/>
+          <a:ln/>
+        </p:spPr>
+        <p:txBody>
+          <a:bodyPr wrap="square" lIns="0" tIns="0" rIns="0" bIns="0" rtlCol="0" anchor="ctr"/>
+          <a:lstStyle/>
+          <a:p>
+            <a:pPr indent="0" marL="0">
+              <a:buNone/>
+            </a:pPr>
+            <a:r>
+              <a:rPr lang="en-US" sz="1400" b="1" dirty="0">
+                <a:solidFill>
+                  <a:srgbClr val="1A1A1A"/>
+                </a:solidFill>
+                <a:latin typeface="Inter" pitchFamily="34" charset="0"/>
+                <a:ea typeface="Inter" pitchFamily="34" charset="-122"/>
+                <a:cs typeface="Inter" pitchFamily="34" charset="-120"/>
+              </a:rPr>
+              <a:t>Subaru Prescott</a:t>
+            </a:r>
+            <a:endParaRPr lang="en-US" sz="1400" dirty="0"/>
+          </a:p>
+        </p:txBody>
+      </p:sp>
+      <p:sp>
+        <p:nvSpPr>
+          <p:cNvPr id="32" name="Text 30"/>
+          <p:cNvSpPr txBox="1"/>
+          <p:nvPr/>
+        </p:nvSpPr>
+        <p:spPr>
+          <a:xfrm>
+            <a:off x="2898648" y="5127955"/>
+            <a:ext cx="1920240" cy="751637"/>
+          </a:xfrm>
+          <a:prstGeom prst="rect">
+            <a:avLst/>
+          </a:prstGeom>
+          <a:noFill/>
+          <a:ln/>
+        </p:spPr>
+        <p:txBody>
+          <a:bodyPr wrap="square" lIns="0" tIns="0" rIns="0" bIns="0" rtlCol="0" anchor="ctr"/>
+          <a:lstStyle/>
+          <a:p>
+            <a:pPr indent="0" marL="0">
+              <a:buNone/>
+            </a:pPr>
+            <a:r>
+              <a:rPr lang="en-US" sz="1400" dirty="0">
+                <a:solidFill>
+                  <a:srgbClr val="595959"/>
+                </a:solidFill>
+                <a:latin typeface="Inter" pitchFamily="34" charset="0"/>
+                <a:ea typeface="Inter" pitchFamily="34" charset="-122"/>
+                <a:cs typeface="Inter" pitchFamily="34" charset="-120"/>
+              </a:rPr>
+              <a:t>$2.33M  </a:t>
+            </a:r>
+            <a:pPr indent="0" marL="0">
+              <a:buNone/>
+            </a:pPr>
+            <a:r>
+              <a:rPr lang="en-US" sz="1400" b="1" dirty="0">
                 <a:solidFill>
                   <a:srgbClr val="0B7A4A"/>
                 </a:solidFill>
@@ -34250,34 +35078,322 @@
                 <a:ea typeface="Inter" pitchFamily="34" charset="-122"/>
                 <a:cs typeface="Inter" pitchFamily="34" charset="-120"/>
               </a:rPr>
-              <a:t>+$7,468,567</a:t>
-            </a:r>
-            <a:endParaRPr lang="en-US" sz="2600" dirty="0"/>
-          </a:p>
-        </p:txBody>
-      </p:sp>
-      <p:sp>
-        <p:nvSpPr>
-          <p:cNvPr id="15" name="Text 13"/>
-          <p:cNvSpPr txBox="1"/>
-          <p:nvPr/>
-        </p:nvSpPr>
-        <p:spPr>
-          <a:xfrm>
-            <a:off x="3657600" y="2734056"/>
-            <a:ext cx="1874520" cy="585216"/>
-          </a:xfrm>
-          <a:prstGeom prst="rect">
-            <a:avLst/>
-          </a:prstGeom>
-          <a:noFill/>
-          <a:ln/>
-        </p:spPr>
-        <p:txBody>
-          <a:bodyPr wrap="square" lIns="0" tIns="0" rIns="0" bIns="0" rtlCol="0" anchor="ctr"/>
-          <a:lstStyle/>
-          <a:p>
-            <a:pPr algn="r" indent="0" marL="0">
+              <a:t>→  </a:t>
+            </a:r>
+            <a:pPr indent="0" marL="0">
+              <a:buNone/>
+            </a:pPr>
+            <a:r>
+              <a:rPr lang="en-US" sz="1400" b="1" dirty="0">
+                <a:solidFill>
+                  <a:srgbClr val="0B7A4A"/>
+                </a:solidFill>
+                <a:latin typeface="Inter" pitchFamily="34" charset="0"/>
+                <a:ea typeface="Inter" pitchFamily="34" charset="-122"/>
+                <a:cs typeface="Inter" pitchFamily="34" charset="-120"/>
+              </a:rPr>
+              <a:t>$2.70M</a:t>
+            </a:r>
+            <a:endParaRPr lang="en-US" sz="1400" dirty="0"/>
+          </a:p>
+        </p:txBody>
+      </p:sp>
+      <p:sp>
+        <p:nvSpPr>
+          <p:cNvPr id="33" name="Text 31"/>
+          <p:cNvSpPr txBox="1"/>
+          <p:nvPr/>
+        </p:nvSpPr>
+        <p:spPr>
+          <a:xfrm>
+            <a:off x="4864608" y="5127955"/>
+            <a:ext cx="1051560" cy="751637"/>
+          </a:xfrm>
+          <a:prstGeom prst="rect">
+            <a:avLst/>
+          </a:prstGeom>
+          <a:noFill/>
+          <a:ln/>
+        </p:spPr>
+        <p:txBody>
+          <a:bodyPr wrap="square" lIns="0" tIns="0" rIns="0" bIns="0" rtlCol="0" anchor="ctr"/>
+          <a:lstStyle/>
+          <a:p>
+            <a:pPr algn="r" indent="0" marL="0">
+              <a:buNone/>
+            </a:pPr>
+            <a:r>
+              <a:rPr lang="en-US" sz="1600" b="1" dirty="0">
+                <a:solidFill>
+                  <a:srgbClr val="0B7A4A"/>
+                </a:solidFill>
+                <a:latin typeface="Inter" pitchFamily="34" charset="0"/>
+                <a:ea typeface="Inter" pitchFamily="34" charset="-122"/>
+                <a:cs typeface="Inter" pitchFamily="34" charset="-120"/>
+              </a:rPr>
+              <a:t>+15.8%</a:t>
+            </a:r>
+            <a:endParaRPr lang="en-US" sz="1600" dirty="0"/>
+          </a:p>
+        </p:txBody>
+      </p:sp>
+      <p:sp>
+        <p:nvSpPr>
+          <p:cNvPr id="34" name="Shape 32"/>
+          <p:cNvSpPr/>
+          <p:nvPr/>
+        </p:nvSpPr>
+        <p:spPr>
+          <a:xfrm>
+            <a:off x="6208776" y="1737360"/>
+            <a:ext cx="5321808" cy="45720"/>
+          </a:xfrm>
+          <a:prstGeom prst="rect">
+            <a:avLst/>
+          </a:prstGeom>
+          <a:solidFill>
+            <a:srgbClr val="C2352F"/>
+          </a:solidFill>
+          <a:ln/>
+        </p:spPr>
+      </p:sp>
+      <p:sp>
+        <p:nvSpPr>
+          <p:cNvPr id="35" name="Text 33"/>
+          <p:cNvSpPr txBox="1"/>
+          <p:nvPr/>
+        </p:nvSpPr>
+        <p:spPr>
+          <a:xfrm>
+            <a:off x="6300216" y="1810512"/>
+            <a:ext cx="1828800" cy="274320"/>
+          </a:xfrm>
+          <a:prstGeom prst="rect">
+            <a:avLst/>
+          </a:prstGeom>
+          <a:noFill/>
+          <a:ln/>
+        </p:spPr>
+        <p:txBody>
+          <a:bodyPr wrap="square" lIns="0" tIns="0" rIns="0" bIns="0" rtlCol="0" anchor="ctr"/>
+          <a:lstStyle/>
+          <a:p>
+            <a:pPr indent="0" marL="0">
+              <a:buNone/>
+            </a:pPr>
+            <a:r>
+              <a:rPr lang="en-US" sz="1400" b="1" spc="100" kern="0" dirty="0">
+                <a:solidFill>
+                  <a:srgbClr val="A82B26"/>
+                </a:solidFill>
+                <a:latin typeface="Inter" pitchFamily="34" charset="0"/>
+                <a:ea typeface="Inter" pitchFamily="34" charset="-122"/>
+                <a:cs typeface="Inter" pitchFamily="34" charset="-120"/>
+              </a:rPr>
+              <a:t>BOTTOM 5</a:t>
+            </a:r>
+            <a:endParaRPr lang="en-US" sz="1400" dirty="0"/>
+          </a:p>
+        </p:txBody>
+      </p:sp>
+      <p:sp>
+        <p:nvSpPr>
+          <p:cNvPr id="36" name="Text 34"/>
+          <p:cNvSpPr txBox="1"/>
+          <p:nvPr/>
+        </p:nvSpPr>
+        <p:spPr>
+          <a:xfrm>
+            <a:off x="8449056" y="1810512"/>
+            <a:ext cx="1828800" cy="274320"/>
+          </a:xfrm>
+          <a:prstGeom prst="rect">
+            <a:avLst/>
+          </a:prstGeom>
+          <a:noFill/>
+          <a:ln/>
+        </p:spPr>
+        <p:txBody>
+          <a:bodyPr wrap="square" lIns="0" tIns="0" rIns="0" bIns="0" rtlCol="0" anchor="ctr"/>
+          <a:lstStyle/>
+          <a:p>
+            <a:pPr indent="0" marL="0">
+              <a:buNone/>
+            </a:pPr>
+            <a:r>
+              <a:rPr lang="en-US" sz="1400" b="1" dirty="0">
+                <a:solidFill>
+                  <a:srgbClr val="595959"/>
+                </a:solidFill>
+                <a:latin typeface="Inter" pitchFamily="34" charset="0"/>
+                <a:ea typeface="Inter" pitchFamily="34" charset="-122"/>
+                <a:cs typeface="Inter" pitchFamily="34" charset="-120"/>
+              </a:rPr>
+              <a:t>2025 → 2026</a:t>
+            </a:r>
+            <a:endParaRPr lang="en-US" sz="1400" dirty="0"/>
+          </a:p>
+        </p:txBody>
+      </p:sp>
+      <p:sp>
+        <p:nvSpPr>
+          <p:cNvPr id="37" name="Text 35"/>
+          <p:cNvSpPr txBox="1"/>
+          <p:nvPr/>
+        </p:nvSpPr>
+        <p:spPr>
+          <a:xfrm>
+            <a:off x="10415016" y="1810512"/>
+            <a:ext cx="1051560" cy="274320"/>
+          </a:xfrm>
+          <a:prstGeom prst="rect">
+            <a:avLst/>
+          </a:prstGeom>
+          <a:noFill/>
+          <a:ln/>
+        </p:spPr>
+        <p:txBody>
+          <a:bodyPr wrap="square" lIns="0" tIns="0" rIns="0" bIns="0" rtlCol="0" anchor="ctr"/>
+          <a:lstStyle/>
+          <a:p>
+            <a:pPr algn="r" indent="0" marL="0">
+              <a:buNone/>
+            </a:pPr>
+            <a:r>
+              <a:rPr lang="en-US" sz="1400" b="1" dirty="0">
+                <a:solidFill>
+                  <a:srgbClr val="595959"/>
+                </a:solidFill>
+                <a:latin typeface="Inter" pitchFamily="34" charset="0"/>
+                <a:ea typeface="Inter" pitchFamily="34" charset="-122"/>
+                <a:cs typeface="Inter" pitchFamily="34" charset="-120"/>
+              </a:rPr>
+              <a:t>Change</a:t>
+            </a:r>
+            <a:endParaRPr lang="en-US" sz="1400" dirty="0"/>
+          </a:p>
+        </p:txBody>
+      </p:sp>
+      <p:sp>
+        <p:nvSpPr>
+          <p:cNvPr id="38" name="Shape 36"/>
+          <p:cNvSpPr/>
+          <p:nvPr/>
+        </p:nvSpPr>
+        <p:spPr>
+          <a:xfrm>
+            <a:off x="6208776" y="2121408"/>
+            <a:ext cx="5321808" cy="751637"/>
+          </a:xfrm>
+          <a:prstGeom prst="rect">
+            <a:avLst/>
+          </a:prstGeom>
+          <a:solidFill>
+            <a:srgbClr val="F7F7F7"/>
+          </a:solidFill>
+          <a:ln/>
+        </p:spPr>
+      </p:sp>
+      <p:sp>
+        <p:nvSpPr>
+          <p:cNvPr id="39" name="Text 37"/>
+          <p:cNvSpPr txBox="1"/>
+          <p:nvPr/>
+        </p:nvSpPr>
+        <p:spPr>
+          <a:xfrm>
+            <a:off x="6300216" y="2121408"/>
+            <a:ext cx="320040" cy="751637"/>
+          </a:xfrm>
+          <a:prstGeom prst="rect">
+            <a:avLst/>
+          </a:prstGeom>
+          <a:noFill/>
+          <a:ln/>
+        </p:spPr>
+        <p:txBody>
+          <a:bodyPr wrap="square" lIns="0" tIns="0" rIns="0" bIns="0" rtlCol="0" anchor="ctr"/>
+          <a:lstStyle/>
+          <a:p>
+            <a:pPr indent="0" marL="0">
+              <a:buNone/>
+            </a:pPr>
+            <a:r>
+              <a:rPr lang="en-US" sz="1500" b="1" dirty="0">
+                <a:solidFill>
+                  <a:srgbClr val="0B2C4A"/>
+                </a:solidFill>
+                <a:latin typeface="Inter" pitchFamily="34" charset="0"/>
+                <a:ea typeface="Inter" pitchFamily="34" charset="-122"/>
+                <a:cs typeface="Inter" pitchFamily="34" charset="-120"/>
+              </a:rPr>
+              <a:t>33</a:t>
+            </a:r>
+            <a:endParaRPr lang="en-US" sz="1500" dirty="0"/>
+          </a:p>
+        </p:txBody>
+      </p:sp>
+      <p:sp>
+        <p:nvSpPr>
+          <p:cNvPr id="40" name="Text 38"/>
+          <p:cNvSpPr txBox="1"/>
+          <p:nvPr/>
+        </p:nvSpPr>
+        <p:spPr>
+          <a:xfrm>
+            <a:off x="6665976" y="2121408"/>
+            <a:ext cx="1737360" cy="751637"/>
+          </a:xfrm>
+          <a:prstGeom prst="rect">
+            <a:avLst/>
+          </a:prstGeom>
+          <a:noFill/>
+          <a:ln/>
+        </p:spPr>
+        <p:txBody>
+          <a:bodyPr wrap="square" lIns="0" tIns="0" rIns="0" bIns="0" rtlCol="0" anchor="ctr"/>
+          <a:lstStyle/>
+          <a:p>
+            <a:pPr indent="0" marL="0">
+              <a:buNone/>
+            </a:pPr>
+            <a:r>
+              <a:rPr lang="en-US" sz="1400" b="1" dirty="0">
+                <a:solidFill>
+                  <a:srgbClr val="1A1A1A"/>
+                </a:solidFill>
+                <a:latin typeface="Inter" pitchFamily="34" charset="0"/>
+                <a:ea typeface="Inter" pitchFamily="34" charset="-122"/>
+                <a:cs typeface="Inter" pitchFamily="34" charset="-120"/>
+              </a:rPr>
+              <a:t>Acura</a:t>
+            </a:r>
+            <a:endParaRPr lang="en-US" sz="1400" dirty="0"/>
+          </a:p>
+        </p:txBody>
+      </p:sp>
+      <p:sp>
+        <p:nvSpPr>
+          <p:cNvPr id="41" name="Text 39"/>
+          <p:cNvSpPr txBox="1"/>
+          <p:nvPr/>
+        </p:nvSpPr>
+        <p:spPr>
+          <a:xfrm>
+            <a:off x="8449056" y="2121408"/>
+            <a:ext cx="1920240" cy="751637"/>
+          </a:xfrm>
+          <a:prstGeom prst="rect">
+            <a:avLst/>
+          </a:prstGeom>
+          <a:noFill/>
+          <a:ln/>
+        </p:spPr>
+        <p:txBody>
+          <a:bodyPr wrap="square" lIns="0" tIns="0" rIns="0" bIns="0" rtlCol="0" anchor="ctr"/>
+          <a:lstStyle/>
+          <a:p>
+            <a:pPr indent="0" marL="0">
               <a:buNone/>
             </a:pPr>
             <a:r>
@@ -34289,7 +35405,35 @@
                 <a:ea typeface="Inter" pitchFamily="34" charset="-122"/>
                 <a:cs typeface="Inter" pitchFamily="34" charset="-120"/>
               </a:rPr>
-              <a:t>same-store growth</a:t>
+              <a:t>$3.41M  </a:t>
+            </a:r>
+            <a:pPr indent="0" marL="0">
+              <a:buNone/>
+            </a:pPr>
+            <a:r>
+              <a:rPr lang="en-US" sz="1400" b="1" dirty="0">
+                <a:solidFill>
+                  <a:srgbClr val="A82B26"/>
+                </a:solidFill>
+                <a:latin typeface="Inter" pitchFamily="34" charset="0"/>
+                <a:ea typeface="Inter" pitchFamily="34" charset="-122"/>
+                <a:cs typeface="Inter" pitchFamily="34" charset="-120"/>
+              </a:rPr>
+              <a:t>→  </a:t>
+            </a:r>
+            <a:pPr indent="0" marL="0">
+              <a:buNone/>
+            </a:pPr>
+            <a:r>
+              <a:rPr lang="en-US" sz="1400" b="1" dirty="0">
+                <a:solidFill>
+                  <a:srgbClr val="A82B26"/>
+                </a:solidFill>
+                <a:latin typeface="Inter" pitchFamily="34" charset="0"/>
+                <a:ea typeface="Inter" pitchFamily="34" charset="-122"/>
+                <a:cs typeface="Inter" pitchFamily="34" charset="-120"/>
+              </a:rPr>
+              <a:t>$2.89M</a:t>
             </a:r>
             <a:endParaRPr lang="en-US" sz="1400" dirty="0"/>
           </a:p>
@@ -34297,73 +35441,829 @@
       </p:sp>
       <p:sp>
         <p:nvSpPr>
-          <p:cNvPr id="16" name="Shape 14"/>
+          <p:cNvPr id="42" name="Text 40"/>
+          <p:cNvSpPr txBox="1"/>
+          <p:nvPr/>
+        </p:nvSpPr>
+        <p:spPr>
+          <a:xfrm>
+            <a:off x="10415016" y="2121408"/>
+            <a:ext cx="1051560" cy="751637"/>
+          </a:xfrm>
+          <a:prstGeom prst="rect">
+            <a:avLst/>
+          </a:prstGeom>
+          <a:noFill/>
+          <a:ln/>
+        </p:spPr>
+        <p:txBody>
+          <a:bodyPr wrap="square" lIns="0" tIns="0" rIns="0" bIns="0" rtlCol="0" anchor="ctr"/>
+          <a:lstStyle/>
+          <a:p>
+            <a:pPr algn="r" indent="0" marL="0">
+              <a:buNone/>
+            </a:pPr>
+            <a:r>
+              <a:rPr lang="en-US" sz="1600" b="1" dirty="0">
+                <a:solidFill>
+                  <a:srgbClr val="A82B26"/>
+                </a:solidFill>
+                <a:latin typeface="Inter" pitchFamily="34" charset="0"/>
+                <a:ea typeface="Inter" pitchFamily="34" charset="-122"/>
+                <a:cs typeface="Inter" pitchFamily="34" charset="-120"/>
+              </a:rPr>
+              <a:t>−15.2%</a:t>
+            </a:r>
+            <a:endParaRPr lang="en-US" sz="1600" dirty="0"/>
+          </a:p>
+        </p:txBody>
+      </p:sp>
+      <p:sp>
+        <p:nvSpPr>
+          <p:cNvPr id="43" name="Text 41"/>
+          <p:cNvSpPr txBox="1"/>
+          <p:nvPr/>
+        </p:nvSpPr>
+        <p:spPr>
+          <a:xfrm>
+            <a:off x="6300216" y="2873045"/>
+            <a:ext cx="320040" cy="751637"/>
+          </a:xfrm>
+          <a:prstGeom prst="rect">
+            <a:avLst/>
+          </a:prstGeom>
+          <a:noFill/>
+          <a:ln/>
+        </p:spPr>
+        <p:txBody>
+          <a:bodyPr wrap="square" lIns="0" tIns="0" rIns="0" bIns="0" rtlCol="0" anchor="ctr"/>
+          <a:lstStyle/>
+          <a:p>
+            <a:pPr indent="0" marL="0">
+              <a:buNone/>
+            </a:pPr>
+            <a:r>
+              <a:rPr lang="en-US" sz="1500" b="1" dirty="0">
+                <a:solidFill>
+                  <a:srgbClr val="0B2C4A"/>
+                </a:solidFill>
+                <a:latin typeface="Inter" pitchFamily="34" charset="0"/>
+                <a:ea typeface="Inter" pitchFamily="34" charset="-122"/>
+                <a:cs typeface="Inter" pitchFamily="34" charset="-120"/>
+              </a:rPr>
+              <a:t>32</a:t>
+            </a:r>
+            <a:endParaRPr lang="en-US" sz="1500" dirty="0"/>
+          </a:p>
+        </p:txBody>
+      </p:sp>
+      <p:sp>
+        <p:nvSpPr>
+          <p:cNvPr id="44" name="Text 42"/>
+          <p:cNvSpPr txBox="1"/>
+          <p:nvPr/>
+        </p:nvSpPr>
+        <p:spPr>
+          <a:xfrm>
+            <a:off x="6665976" y="2873045"/>
+            <a:ext cx="1737360" cy="751637"/>
+          </a:xfrm>
+          <a:prstGeom prst="rect">
+            <a:avLst/>
+          </a:prstGeom>
+          <a:noFill/>
+          <a:ln/>
+        </p:spPr>
+        <p:txBody>
+          <a:bodyPr wrap="square" lIns="0" tIns="0" rIns="0" bIns="0" rtlCol="0" anchor="ctr"/>
+          <a:lstStyle/>
+          <a:p>
+            <a:pPr indent="0" marL="0">
+              <a:buNone/>
+            </a:pPr>
+            <a:r>
+              <a:rPr lang="en-US" sz="1400" b="1" dirty="0">
+                <a:solidFill>
+                  <a:srgbClr val="1A1A1A"/>
+                </a:solidFill>
+                <a:latin typeface="Inter" pitchFamily="34" charset="0"/>
+                <a:ea typeface="Inter" pitchFamily="34" charset="-122"/>
+                <a:cs typeface="Inter" pitchFamily="34" charset="-120"/>
+              </a:rPr>
+              <a:t>VW St George</a:t>
+            </a:r>
+            <a:endParaRPr lang="en-US" sz="1400" dirty="0"/>
+          </a:p>
+        </p:txBody>
+      </p:sp>
+      <p:sp>
+        <p:nvSpPr>
+          <p:cNvPr id="45" name="Text 43"/>
+          <p:cNvSpPr txBox="1"/>
+          <p:nvPr/>
+        </p:nvSpPr>
+        <p:spPr>
+          <a:xfrm>
+            <a:off x="8449056" y="2873045"/>
+            <a:ext cx="1920240" cy="751637"/>
+          </a:xfrm>
+          <a:prstGeom prst="rect">
+            <a:avLst/>
+          </a:prstGeom>
+          <a:noFill/>
+          <a:ln/>
+        </p:spPr>
+        <p:txBody>
+          <a:bodyPr wrap="square" lIns="0" tIns="0" rIns="0" bIns="0" rtlCol="0" anchor="ctr"/>
+          <a:lstStyle/>
+          <a:p>
+            <a:pPr indent="0" marL="0">
+              <a:buNone/>
+            </a:pPr>
+            <a:r>
+              <a:rPr lang="en-US" sz="1400" dirty="0">
+                <a:solidFill>
+                  <a:srgbClr val="595959"/>
+                </a:solidFill>
+                <a:latin typeface="Inter" pitchFamily="34" charset="0"/>
+                <a:ea typeface="Inter" pitchFamily="34" charset="-122"/>
+                <a:cs typeface="Inter" pitchFamily="34" charset="-120"/>
+              </a:rPr>
+              <a:t>$1.13M  </a:t>
+            </a:r>
+            <a:pPr indent="0" marL="0">
+              <a:buNone/>
+            </a:pPr>
+            <a:r>
+              <a:rPr lang="en-US" sz="1400" b="1" dirty="0">
+                <a:solidFill>
+                  <a:srgbClr val="A82B26"/>
+                </a:solidFill>
+                <a:latin typeface="Inter" pitchFamily="34" charset="0"/>
+                <a:ea typeface="Inter" pitchFamily="34" charset="-122"/>
+                <a:cs typeface="Inter" pitchFamily="34" charset="-120"/>
+              </a:rPr>
+              <a:t>→  </a:t>
+            </a:r>
+            <a:pPr indent="0" marL="0">
+              <a:buNone/>
+            </a:pPr>
+            <a:r>
+              <a:rPr lang="en-US" sz="1400" b="1" dirty="0">
+                <a:solidFill>
+                  <a:srgbClr val="A82B26"/>
+                </a:solidFill>
+                <a:latin typeface="Inter" pitchFamily="34" charset="0"/>
+                <a:ea typeface="Inter" pitchFamily="34" charset="-122"/>
+                <a:cs typeface="Inter" pitchFamily="34" charset="-120"/>
+              </a:rPr>
+              <a:t>$968K</a:t>
+            </a:r>
+            <a:endParaRPr lang="en-US" sz="1400" dirty="0"/>
+          </a:p>
+        </p:txBody>
+      </p:sp>
+      <p:sp>
+        <p:nvSpPr>
+          <p:cNvPr id="46" name="Text 44"/>
+          <p:cNvSpPr txBox="1"/>
+          <p:nvPr/>
+        </p:nvSpPr>
+        <p:spPr>
+          <a:xfrm>
+            <a:off x="10415016" y="2873045"/>
+            <a:ext cx="1051560" cy="751637"/>
+          </a:xfrm>
+          <a:prstGeom prst="rect">
+            <a:avLst/>
+          </a:prstGeom>
+          <a:noFill/>
+          <a:ln/>
+        </p:spPr>
+        <p:txBody>
+          <a:bodyPr wrap="square" lIns="0" tIns="0" rIns="0" bIns="0" rtlCol="0" anchor="ctr"/>
+          <a:lstStyle/>
+          <a:p>
+            <a:pPr algn="r" indent="0" marL="0">
+              <a:buNone/>
+            </a:pPr>
+            <a:r>
+              <a:rPr lang="en-US" sz="1600" b="1" dirty="0">
+                <a:solidFill>
+                  <a:srgbClr val="A82B26"/>
+                </a:solidFill>
+                <a:latin typeface="Inter" pitchFamily="34" charset="0"/>
+                <a:ea typeface="Inter" pitchFamily="34" charset="-122"/>
+                <a:cs typeface="Inter" pitchFamily="34" charset="-120"/>
+              </a:rPr>
+              <a:t>−14.4%</a:t>
+            </a:r>
+            <a:endParaRPr lang="en-US" sz="1600" dirty="0"/>
+          </a:p>
+        </p:txBody>
+      </p:sp>
+      <p:sp>
+        <p:nvSpPr>
+          <p:cNvPr id="47" name="Shape 45"/>
           <p:cNvSpPr/>
           <p:nvPr/>
         </p:nvSpPr>
         <p:spPr>
           <a:xfrm>
-            <a:off x="987552" y="3401568"/>
-            <a:ext cx="292608" cy="292608"/>
-          </a:xfrm>
-          <a:prstGeom prst="ellipse">
+            <a:off x="6208776" y="3624682"/>
+            <a:ext cx="5321808" cy="751637"/>
+          </a:xfrm>
+          <a:prstGeom prst="rect">
             <a:avLst/>
           </a:prstGeom>
           <a:solidFill>
-            <a:srgbClr val="0B2C4A"/>
+            <a:srgbClr val="F7F7F7"/>
           </a:solidFill>
           <a:ln/>
         </p:spPr>
       </p:sp>
       <p:sp>
         <p:nvSpPr>
-          <p:cNvPr id="17" name="Text 15"/>
-          <p:cNvSpPr txBox="1"/>
-          <p:nvPr/>
-        </p:nvSpPr>
-        <p:spPr>
-          <a:xfrm>
-            <a:off x="987552" y="3401568"/>
-            <a:ext cx="292608" cy="292608"/>
-          </a:xfrm>
-          <a:prstGeom prst="rect">
-            <a:avLst/>
-          </a:prstGeom>
-          <a:noFill/>
-          <a:ln/>
-        </p:spPr>
-        <p:txBody>
-          <a:bodyPr wrap="square" lIns="0" tIns="0" rIns="0" bIns="0" rtlCol="0" anchor="ctr"/>
-          <a:lstStyle/>
-          <a:p>
-            <a:pPr algn="ctr" indent="0" marL="0">
-              <a:buNone/>
-            </a:pPr>
-            <a:r>
-              <a:rPr lang="en-US" sz="1800" b="1" dirty="0">
-                <a:solidFill>
-                  <a:srgbClr val="FFFFFF"/>
-                </a:solidFill>
-                <a:latin typeface="Inter" pitchFamily="34" charset="0"/>
-                <a:ea typeface="Inter" pitchFamily="34" charset="-122"/>
-                <a:cs typeface="Inter" pitchFamily="34" charset="-120"/>
-              </a:rPr>
-              <a:t>=</a:t>
-            </a:r>
-            <a:endParaRPr lang="en-US" sz="1800" dirty="0"/>
-          </a:p>
-        </p:txBody>
-      </p:sp>
-      <p:sp>
-        <p:nvSpPr>
-          <p:cNvPr id="18" name="Shape 16"/>
+          <p:cNvPr id="48" name="Text 46"/>
+          <p:cNvSpPr txBox="1"/>
+          <p:nvPr/>
+        </p:nvSpPr>
+        <p:spPr>
+          <a:xfrm>
+            <a:off x="6300216" y="3624682"/>
+            <a:ext cx="320040" cy="751637"/>
+          </a:xfrm>
+          <a:prstGeom prst="rect">
+            <a:avLst/>
+          </a:prstGeom>
+          <a:noFill/>
+          <a:ln/>
+        </p:spPr>
+        <p:txBody>
+          <a:bodyPr wrap="square" lIns="0" tIns="0" rIns="0" bIns="0" rtlCol="0" anchor="ctr"/>
+          <a:lstStyle/>
+          <a:p>
+            <a:pPr indent="0" marL="0">
+              <a:buNone/>
+            </a:pPr>
+            <a:r>
+              <a:rPr lang="en-US" sz="1500" b="1" dirty="0">
+                <a:solidFill>
+                  <a:srgbClr val="0B2C4A"/>
+                </a:solidFill>
+                <a:latin typeface="Inter" pitchFamily="34" charset="0"/>
+                <a:ea typeface="Inter" pitchFamily="34" charset="-122"/>
+                <a:cs typeface="Inter" pitchFamily="34" charset="-120"/>
+              </a:rPr>
+              <a:t>31</a:t>
+            </a:r>
+            <a:endParaRPr lang="en-US" sz="1500" dirty="0"/>
+          </a:p>
+        </p:txBody>
+      </p:sp>
+      <p:sp>
+        <p:nvSpPr>
+          <p:cNvPr id="49" name="Text 47"/>
+          <p:cNvSpPr txBox="1"/>
+          <p:nvPr/>
+        </p:nvSpPr>
+        <p:spPr>
+          <a:xfrm>
+            <a:off x="6665976" y="3624682"/>
+            <a:ext cx="1737360" cy="751637"/>
+          </a:xfrm>
+          <a:prstGeom prst="rect">
+            <a:avLst/>
+          </a:prstGeom>
+          <a:noFill/>
+          <a:ln/>
+        </p:spPr>
+        <p:txBody>
+          <a:bodyPr wrap="square" lIns="0" tIns="0" rIns="0" bIns="0" rtlCol="0" anchor="ctr"/>
+          <a:lstStyle/>
+          <a:p>
+            <a:pPr indent="0" marL="0">
+              <a:buNone/>
+            </a:pPr>
+            <a:r>
+              <a:rPr lang="en-US" sz="1400" b="1" dirty="0">
+                <a:solidFill>
+                  <a:srgbClr val="1A1A1A"/>
+                </a:solidFill>
+                <a:latin typeface="Inter" pitchFamily="34" charset="0"/>
+                <a:ea typeface="Inter" pitchFamily="34" charset="-122"/>
+                <a:cs typeface="Inter" pitchFamily="34" charset="-120"/>
+              </a:rPr>
+              <a:t>VW Henderson</a:t>
+            </a:r>
+            <a:endParaRPr lang="en-US" sz="1400" dirty="0"/>
+          </a:p>
+        </p:txBody>
+      </p:sp>
+      <p:sp>
+        <p:nvSpPr>
+          <p:cNvPr id="50" name="Text 48"/>
+          <p:cNvSpPr txBox="1"/>
+          <p:nvPr/>
+        </p:nvSpPr>
+        <p:spPr>
+          <a:xfrm>
+            <a:off x="8449056" y="3624682"/>
+            <a:ext cx="1920240" cy="751637"/>
+          </a:xfrm>
+          <a:prstGeom prst="rect">
+            <a:avLst/>
+          </a:prstGeom>
+          <a:noFill/>
+          <a:ln/>
+        </p:spPr>
+        <p:txBody>
+          <a:bodyPr wrap="square" lIns="0" tIns="0" rIns="0" bIns="0" rtlCol="0" anchor="ctr"/>
+          <a:lstStyle/>
+          <a:p>
+            <a:pPr indent="0" marL="0">
+              <a:buNone/>
+            </a:pPr>
+            <a:r>
+              <a:rPr lang="en-US" sz="1400" dirty="0">
+                <a:solidFill>
+                  <a:srgbClr val="595959"/>
+                </a:solidFill>
+                <a:latin typeface="Inter" pitchFamily="34" charset="0"/>
+                <a:ea typeface="Inter" pitchFamily="34" charset="-122"/>
+                <a:cs typeface="Inter" pitchFamily="34" charset="-120"/>
+              </a:rPr>
+              <a:t>$5.55M  </a:t>
+            </a:r>
+            <a:pPr indent="0" marL="0">
+              <a:buNone/>
+            </a:pPr>
+            <a:r>
+              <a:rPr lang="en-US" sz="1400" b="1" dirty="0">
+                <a:solidFill>
+                  <a:srgbClr val="A82B26"/>
+                </a:solidFill>
+                <a:latin typeface="Inter" pitchFamily="34" charset="0"/>
+                <a:ea typeface="Inter" pitchFamily="34" charset="-122"/>
+                <a:cs typeface="Inter" pitchFamily="34" charset="-120"/>
+              </a:rPr>
+              <a:t>→  </a:t>
+            </a:r>
+            <a:pPr indent="0" marL="0">
+              <a:buNone/>
+            </a:pPr>
+            <a:r>
+              <a:rPr lang="en-US" sz="1400" b="1" dirty="0">
+                <a:solidFill>
+                  <a:srgbClr val="A82B26"/>
+                </a:solidFill>
+                <a:latin typeface="Inter" pitchFamily="34" charset="0"/>
+                <a:ea typeface="Inter" pitchFamily="34" charset="-122"/>
+                <a:cs typeface="Inter" pitchFamily="34" charset="-120"/>
+              </a:rPr>
+              <a:t>$4.79M</a:t>
+            </a:r>
+            <a:endParaRPr lang="en-US" sz="1400" dirty="0"/>
+          </a:p>
+        </p:txBody>
+      </p:sp>
+      <p:sp>
+        <p:nvSpPr>
+          <p:cNvPr id="51" name="Text 49"/>
+          <p:cNvSpPr txBox="1"/>
+          <p:nvPr/>
+        </p:nvSpPr>
+        <p:spPr>
+          <a:xfrm>
+            <a:off x="10415016" y="3624682"/>
+            <a:ext cx="1051560" cy="751637"/>
+          </a:xfrm>
+          <a:prstGeom prst="rect">
+            <a:avLst/>
+          </a:prstGeom>
+          <a:noFill/>
+          <a:ln/>
+        </p:spPr>
+        <p:txBody>
+          <a:bodyPr wrap="square" lIns="0" tIns="0" rIns="0" bIns="0" rtlCol="0" anchor="ctr"/>
+          <a:lstStyle/>
+          <a:p>
+            <a:pPr algn="r" indent="0" marL="0">
+              <a:buNone/>
+            </a:pPr>
+            <a:r>
+              <a:rPr lang="en-US" sz="1600" b="1" dirty="0">
+                <a:solidFill>
+                  <a:srgbClr val="A82B26"/>
+                </a:solidFill>
+                <a:latin typeface="Inter" pitchFamily="34" charset="0"/>
+                <a:ea typeface="Inter" pitchFamily="34" charset="-122"/>
+                <a:cs typeface="Inter" pitchFamily="34" charset="-120"/>
+              </a:rPr>
+              <a:t>−13.7%</a:t>
+            </a:r>
+            <a:endParaRPr lang="en-US" sz="1600" dirty="0"/>
+          </a:p>
+        </p:txBody>
+      </p:sp>
+      <p:sp>
+        <p:nvSpPr>
+          <p:cNvPr id="52" name="Text 50"/>
+          <p:cNvSpPr txBox="1"/>
+          <p:nvPr/>
+        </p:nvSpPr>
+        <p:spPr>
+          <a:xfrm>
+            <a:off x="6300216" y="4376318"/>
+            <a:ext cx="320040" cy="751637"/>
+          </a:xfrm>
+          <a:prstGeom prst="rect">
+            <a:avLst/>
+          </a:prstGeom>
+          <a:noFill/>
+          <a:ln/>
+        </p:spPr>
+        <p:txBody>
+          <a:bodyPr wrap="square" lIns="0" tIns="0" rIns="0" bIns="0" rtlCol="0" anchor="ctr"/>
+          <a:lstStyle/>
+          <a:p>
+            <a:pPr indent="0" marL="0">
+              <a:buNone/>
+            </a:pPr>
+            <a:r>
+              <a:rPr lang="en-US" sz="1500" b="1" dirty="0">
+                <a:solidFill>
+                  <a:srgbClr val="0B2C4A"/>
+                </a:solidFill>
+                <a:latin typeface="Inter" pitchFamily="34" charset="0"/>
+                <a:ea typeface="Inter" pitchFamily="34" charset="-122"/>
+                <a:cs typeface="Inter" pitchFamily="34" charset="-120"/>
+              </a:rPr>
+              <a:t>30</a:t>
+            </a:r>
+            <a:endParaRPr lang="en-US" sz="1500" dirty="0"/>
+          </a:p>
+        </p:txBody>
+      </p:sp>
+      <p:sp>
+        <p:nvSpPr>
+          <p:cNvPr id="53" name="Text 51"/>
+          <p:cNvSpPr txBox="1"/>
+          <p:nvPr/>
+        </p:nvSpPr>
+        <p:spPr>
+          <a:xfrm>
+            <a:off x="6665976" y="4376318"/>
+            <a:ext cx="1737360" cy="751637"/>
+          </a:xfrm>
+          <a:prstGeom prst="rect">
+            <a:avLst/>
+          </a:prstGeom>
+          <a:noFill/>
+          <a:ln/>
+        </p:spPr>
+        <p:txBody>
+          <a:bodyPr wrap="square" lIns="0" tIns="0" rIns="0" bIns="0" rtlCol="0" anchor="ctr"/>
+          <a:lstStyle/>
+          <a:p>
+            <a:pPr indent="0" marL="0">
+              <a:buNone/>
+            </a:pPr>
+            <a:r>
+              <a:rPr lang="en-US" sz="1400" b="1" dirty="0">
+                <a:solidFill>
+                  <a:srgbClr val="1A1A1A"/>
+                </a:solidFill>
+                <a:latin typeface="Inter" pitchFamily="34" charset="0"/>
+                <a:ea typeface="Inter" pitchFamily="34" charset="-122"/>
+                <a:cs typeface="Inter" pitchFamily="34" charset="-120"/>
+              </a:rPr>
+              <a:t>Audi Reno</a:t>
+            </a:r>
+            <a:endParaRPr lang="en-US" sz="1400" dirty="0"/>
+          </a:p>
+        </p:txBody>
+      </p:sp>
+      <p:sp>
+        <p:nvSpPr>
+          <p:cNvPr id="54" name="Text 52"/>
+          <p:cNvSpPr txBox="1"/>
+          <p:nvPr/>
+        </p:nvSpPr>
+        <p:spPr>
+          <a:xfrm>
+            <a:off x="8449056" y="4376318"/>
+            <a:ext cx="1920240" cy="751637"/>
+          </a:xfrm>
+          <a:prstGeom prst="rect">
+            <a:avLst/>
+          </a:prstGeom>
+          <a:noFill/>
+          <a:ln/>
+        </p:spPr>
+        <p:txBody>
+          <a:bodyPr wrap="square" lIns="0" tIns="0" rIns="0" bIns="0" rtlCol="0" anchor="ctr"/>
+          <a:lstStyle/>
+          <a:p>
+            <a:pPr indent="0" marL="0">
+              <a:buNone/>
+            </a:pPr>
+            <a:r>
+              <a:rPr lang="en-US" sz="1400" dirty="0">
+                <a:solidFill>
+                  <a:srgbClr val="595959"/>
+                </a:solidFill>
+                <a:latin typeface="Inter" pitchFamily="34" charset="0"/>
+                <a:ea typeface="Inter" pitchFamily="34" charset="-122"/>
+                <a:cs typeface="Inter" pitchFamily="34" charset="-120"/>
+              </a:rPr>
+              <a:t>$4.98M  </a:t>
+            </a:r>
+            <a:pPr indent="0" marL="0">
+              <a:buNone/>
+            </a:pPr>
+            <a:r>
+              <a:rPr lang="en-US" sz="1400" b="1" dirty="0">
+                <a:solidFill>
+                  <a:srgbClr val="A82B26"/>
+                </a:solidFill>
+                <a:latin typeface="Inter" pitchFamily="34" charset="0"/>
+                <a:ea typeface="Inter" pitchFamily="34" charset="-122"/>
+                <a:cs typeface="Inter" pitchFamily="34" charset="-120"/>
+              </a:rPr>
+              <a:t>→  </a:t>
+            </a:r>
+            <a:pPr indent="0" marL="0">
+              <a:buNone/>
+            </a:pPr>
+            <a:r>
+              <a:rPr lang="en-US" sz="1400" b="1" dirty="0">
+                <a:solidFill>
+                  <a:srgbClr val="A82B26"/>
+                </a:solidFill>
+                <a:latin typeface="Inter" pitchFamily="34" charset="0"/>
+                <a:ea typeface="Inter" pitchFamily="34" charset="-122"/>
+                <a:cs typeface="Inter" pitchFamily="34" charset="-120"/>
+              </a:rPr>
+              <a:t>$4.46M</a:t>
+            </a:r>
+            <a:endParaRPr lang="en-US" sz="1400" dirty="0"/>
+          </a:p>
+        </p:txBody>
+      </p:sp>
+      <p:sp>
+        <p:nvSpPr>
+          <p:cNvPr id="55" name="Text 53"/>
+          <p:cNvSpPr txBox="1"/>
+          <p:nvPr/>
+        </p:nvSpPr>
+        <p:spPr>
+          <a:xfrm>
+            <a:off x="10415016" y="4376318"/>
+            <a:ext cx="1051560" cy="751637"/>
+          </a:xfrm>
+          <a:prstGeom prst="rect">
+            <a:avLst/>
+          </a:prstGeom>
+          <a:noFill/>
+          <a:ln/>
+        </p:spPr>
+        <p:txBody>
+          <a:bodyPr wrap="square" lIns="0" tIns="0" rIns="0" bIns="0" rtlCol="0" anchor="ctr"/>
+          <a:lstStyle/>
+          <a:p>
+            <a:pPr algn="r" indent="0" marL="0">
+              <a:buNone/>
+            </a:pPr>
+            <a:r>
+              <a:rPr lang="en-US" sz="1600" b="1" dirty="0">
+                <a:solidFill>
+                  <a:srgbClr val="A82B26"/>
+                </a:solidFill>
+                <a:latin typeface="Inter" pitchFamily="34" charset="0"/>
+                <a:ea typeface="Inter" pitchFamily="34" charset="-122"/>
+                <a:cs typeface="Inter" pitchFamily="34" charset="-120"/>
+              </a:rPr>
+              <a:t>−10.4%</a:t>
+            </a:r>
+            <a:endParaRPr lang="en-US" sz="1600" dirty="0"/>
+          </a:p>
+        </p:txBody>
+      </p:sp>
+      <p:sp>
+        <p:nvSpPr>
+          <p:cNvPr id="56" name="Shape 54"/>
           <p:cNvSpPr/>
           <p:nvPr/>
         </p:nvSpPr>
         <p:spPr>
           <a:xfrm>
-            <a:off x="713232" y="3712464"/>
-            <a:ext cx="4974336" cy="713232"/>
+            <a:off x="6208776" y="5127955"/>
+            <a:ext cx="5321808" cy="751637"/>
+          </a:xfrm>
+          <a:prstGeom prst="rect">
+            <a:avLst/>
+          </a:prstGeom>
+          <a:solidFill>
+            <a:srgbClr val="F7F7F7"/>
+          </a:solidFill>
+          <a:ln/>
+        </p:spPr>
+      </p:sp>
+      <p:sp>
+        <p:nvSpPr>
+          <p:cNvPr id="57" name="Text 55"/>
+          <p:cNvSpPr txBox="1"/>
+          <p:nvPr/>
+        </p:nvSpPr>
+        <p:spPr>
+          <a:xfrm>
+            <a:off x="6300216" y="5127955"/>
+            <a:ext cx="320040" cy="751637"/>
+          </a:xfrm>
+          <a:prstGeom prst="rect">
+            <a:avLst/>
+          </a:prstGeom>
+          <a:noFill/>
+          <a:ln/>
+        </p:spPr>
+        <p:txBody>
+          <a:bodyPr wrap="square" lIns="0" tIns="0" rIns="0" bIns="0" rtlCol="0" anchor="ctr"/>
+          <a:lstStyle/>
+          <a:p>
+            <a:pPr indent="0" marL="0">
+              <a:buNone/>
+            </a:pPr>
+            <a:r>
+              <a:rPr lang="en-US" sz="1500" b="1" dirty="0">
+                <a:solidFill>
+                  <a:srgbClr val="0B2C4A"/>
+                </a:solidFill>
+                <a:latin typeface="Inter" pitchFamily="34" charset="0"/>
+                <a:ea typeface="Inter" pitchFamily="34" charset="-122"/>
+                <a:cs typeface="Inter" pitchFamily="34" charset="-120"/>
+              </a:rPr>
+              <a:t>29</a:t>
+            </a:r>
+            <a:endParaRPr lang="en-US" sz="1500" dirty="0"/>
+          </a:p>
+        </p:txBody>
+      </p:sp>
+      <p:sp>
+        <p:nvSpPr>
+          <p:cNvPr id="58" name="Text 56"/>
+          <p:cNvSpPr txBox="1"/>
+          <p:nvPr/>
+        </p:nvSpPr>
+        <p:spPr>
+          <a:xfrm>
+            <a:off x="6665976" y="5127955"/>
+            <a:ext cx="1737360" cy="751637"/>
+          </a:xfrm>
+          <a:prstGeom prst="rect">
+            <a:avLst/>
+          </a:prstGeom>
+          <a:noFill/>
+          <a:ln/>
+        </p:spPr>
+        <p:txBody>
+          <a:bodyPr wrap="square" lIns="0" tIns="0" rIns="0" bIns="0" rtlCol="0" anchor="ctr"/>
+          <a:lstStyle/>
+          <a:p>
+            <a:pPr indent="0" marL="0">
+              <a:buNone/>
+            </a:pPr>
+            <a:r>
+              <a:rPr lang="en-US" sz="1400" b="1" dirty="0">
+                <a:solidFill>
+                  <a:srgbClr val="1A1A1A"/>
+                </a:solidFill>
+                <a:latin typeface="Inter" pitchFamily="34" charset="0"/>
+                <a:ea typeface="Inter" pitchFamily="34" charset="-122"/>
+                <a:cs typeface="Inter" pitchFamily="34" charset="-120"/>
+              </a:rPr>
+              <a:t>Honda North</a:t>
+            </a:r>
+            <a:endParaRPr lang="en-US" sz="1400" dirty="0"/>
+          </a:p>
+        </p:txBody>
+      </p:sp>
+      <p:sp>
+        <p:nvSpPr>
+          <p:cNvPr id="59" name="Text 57"/>
+          <p:cNvSpPr txBox="1"/>
+          <p:nvPr/>
+        </p:nvSpPr>
+        <p:spPr>
+          <a:xfrm>
+            <a:off x="8449056" y="5127955"/>
+            <a:ext cx="1920240" cy="751637"/>
+          </a:xfrm>
+          <a:prstGeom prst="rect">
+            <a:avLst/>
+          </a:prstGeom>
+          <a:noFill/>
+          <a:ln/>
+        </p:spPr>
+        <p:txBody>
+          <a:bodyPr wrap="square" lIns="0" tIns="0" rIns="0" bIns="0" rtlCol="0" anchor="ctr"/>
+          <a:lstStyle/>
+          <a:p>
+            <a:pPr indent="0" marL="0">
+              <a:buNone/>
+            </a:pPr>
+            <a:r>
+              <a:rPr lang="en-US" sz="1400" dirty="0">
+                <a:solidFill>
+                  <a:srgbClr val="595959"/>
+                </a:solidFill>
+                <a:latin typeface="Inter" pitchFamily="34" charset="0"/>
+                <a:ea typeface="Inter" pitchFamily="34" charset="-122"/>
+                <a:cs typeface="Inter" pitchFamily="34" charset="-120"/>
+              </a:rPr>
+              <a:t>$9.46M  </a:t>
+            </a:r>
+            <a:pPr indent="0" marL="0">
+              <a:buNone/>
+            </a:pPr>
+            <a:r>
+              <a:rPr lang="en-US" sz="1400" b="1" dirty="0">
+                <a:solidFill>
+                  <a:srgbClr val="A82B26"/>
+                </a:solidFill>
+                <a:latin typeface="Inter" pitchFamily="34" charset="0"/>
+                <a:ea typeface="Inter" pitchFamily="34" charset="-122"/>
+                <a:cs typeface="Inter" pitchFamily="34" charset="-120"/>
+              </a:rPr>
+              <a:t>→  </a:t>
+            </a:r>
+            <a:pPr indent="0" marL="0">
+              <a:buNone/>
+            </a:pPr>
+            <a:r>
+              <a:rPr lang="en-US" sz="1400" b="1" dirty="0">
+                <a:solidFill>
+                  <a:srgbClr val="A82B26"/>
+                </a:solidFill>
+                <a:latin typeface="Inter" pitchFamily="34" charset="0"/>
+                <a:ea typeface="Inter" pitchFamily="34" charset="-122"/>
+                <a:cs typeface="Inter" pitchFamily="34" charset="-120"/>
+              </a:rPr>
+              <a:t>$8.62M</a:t>
+            </a:r>
+            <a:endParaRPr lang="en-US" sz="1400" dirty="0"/>
+          </a:p>
+        </p:txBody>
+      </p:sp>
+      <p:sp>
+        <p:nvSpPr>
+          <p:cNvPr id="60" name="Text 58"/>
+          <p:cNvSpPr txBox="1"/>
+          <p:nvPr/>
+        </p:nvSpPr>
+        <p:spPr>
+          <a:xfrm>
+            <a:off x="10415016" y="5127955"/>
+            <a:ext cx="1051560" cy="751637"/>
+          </a:xfrm>
+          <a:prstGeom prst="rect">
+            <a:avLst/>
+          </a:prstGeom>
+          <a:noFill/>
+          <a:ln/>
+        </p:spPr>
+        <p:txBody>
+          <a:bodyPr wrap="square" lIns="0" tIns="0" rIns="0" bIns="0" rtlCol="0" anchor="ctr"/>
+          <a:lstStyle/>
+          <a:p>
+            <a:pPr algn="r" indent="0" marL="0">
+              <a:buNone/>
+            </a:pPr>
+            <a:r>
+              <a:rPr lang="en-US" sz="1600" b="1" dirty="0">
+                <a:solidFill>
+                  <a:srgbClr val="A82B26"/>
+                </a:solidFill>
+                <a:latin typeface="Inter" pitchFamily="34" charset="0"/>
+                <a:ea typeface="Inter" pitchFamily="34" charset="-122"/>
+                <a:cs typeface="Inter" pitchFamily="34" charset="-120"/>
+              </a:rPr>
+              <a:t>−8.9%</a:t>
+            </a:r>
+            <a:endParaRPr lang="en-US" sz="1600" dirty="0"/>
+          </a:p>
+        </p:txBody>
+      </p:sp>
+      <p:sp>
+        <p:nvSpPr>
+          <p:cNvPr id="61" name="Shape 59"/>
+          <p:cNvSpPr/>
+          <p:nvPr/>
+        </p:nvSpPr>
+        <p:spPr>
+          <a:xfrm>
+            <a:off x="457200" y="6126480"/>
+            <a:ext cx="11274552" cy="615696"/>
           </a:xfrm>
           <a:prstGeom prst="rect">
             <a:avLst/>
@@ -34376,14 +36276,14 @@
       </p:sp>
       <p:sp>
         <p:nvSpPr>
-          <p:cNvPr id="19" name="Text 17"/>
-          <p:cNvSpPr txBox="1"/>
-          <p:nvPr/>
-        </p:nvSpPr>
-        <p:spPr>
-          <a:xfrm>
-            <a:off x="896112" y="3739896"/>
-            <a:ext cx="2743200" cy="512064"/>
+          <p:cNvPr id="62" name="Text 60"/>
+          <p:cNvSpPr txBox="1"/>
+          <p:nvPr/>
+        </p:nvSpPr>
+        <p:spPr>
+          <a:xfrm>
+            <a:off x="658368" y="6144768"/>
+            <a:ext cx="10927080" cy="579120"/>
           </a:xfrm>
           <a:prstGeom prst="rect">
             <a:avLst/>
@@ -34399,7 +36299,7 @@
               <a:buNone/>
             </a:pPr>
             <a:r>
-              <a:rPr lang="en-US" sz="3000" b="1" dirty="0">
+              <a:rPr lang="en-US" sz="1600" b="1" dirty="0">
                 <a:solidFill>
                   <a:srgbClr val="0B2C4A"/>
                 </a:solidFill>
@@ -34407,1086 +36307,7 @@
                 <a:ea typeface="Inter" pitchFamily="34" charset="-122"/>
                 <a:cs typeface="Inter" pitchFamily="34" charset="-120"/>
               </a:rPr>
-              <a:t>$188.80M</a:t>
-            </a:r>
-            <a:endParaRPr lang="en-US" sz="3000" dirty="0"/>
-          </a:p>
-        </p:txBody>
-      </p:sp>
-      <p:sp>
-        <p:nvSpPr>
-          <p:cNvPr id="20" name="Text 18"/>
-          <p:cNvSpPr txBox="1"/>
-          <p:nvPr/>
-        </p:nvSpPr>
-        <p:spPr>
-          <a:xfrm>
-            <a:off x="3657600" y="3739896"/>
-            <a:ext cx="1874520" cy="658368"/>
-          </a:xfrm>
-          <a:prstGeom prst="rect">
-            <a:avLst/>
-          </a:prstGeom>
-          <a:noFill/>
-          <a:ln/>
-        </p:spPr>
-        <p:txBody>
-          <a:bodyPr wrap="square" lIns="0" tIns="0" rIns="0" bIns="0" rtlCol="0" anchor="ctr"/>
-          <a:lstStyle/>
-          <a:p>
-            <a:pPr algn="r" indent="0" marL="0">
-              <a:buNone/>
-            </a:pPr>
-            <a:r>
-              <a:rPr lang="en-US" sz="1400" dirty="0">
-                <a:solidFill>
-                  <a:srgbClr val="595959"/>
-                </a:solidFill>
-                <a:latin typeface="Inter" pitchFamily="34" charset="0"/>
-                <a:ea typeface="Inter" pitchFamily="34" charset="-122"/>
-                <a:cs typeface="Inter" pitchFamily="34" charset="-120"/>
-              </a:rPr>
-              <a:t>2026 group</a:t>
-            </a:r>
-            <a:endParaRPr lang="en-US" sz="1400" dirty="0"/>
-          </a:p>
-        </p:txBody>
-      </p:sp>
-      <p:sp>
-        <p:nvSpPr>
-          <p:cNvPr id="21" name="Shape 19"/>
-          <p:cNvSpPr/>
-          <p:nvPr/>
-        </p:nvSpPr>
-        <p:spPr>
-          <a:xfrm>
-            <a:off x="6126480" y="1207008"/>
-            <a:ext cx="5605272" cy="4782312"/>
-          </a:xfrm>
-          <a:prstGeom prst="rect">
-            <a:avLst/>
-          </a:prstGeom>
-          <a:solidFill>
-            <a:srgbClr val="FFFFFF"/>
-          </a:solidFill>
-          <a:ln/>
-        </p:spPr>
-      </p:sp>
-      <p:sp>
-        <p:nvSpPr>
-          <p:cNvPr id="22" name="Text 20"/>
-          <p:cNvSpPr txBox="1"/>
-          <p:nvPr/>
-        </p:nvSpPr>
-        <p:spPr>
-          <a:xfrm>
-            <a:off x="6355080" y="1344168"/>
-            <a:ext cx="5148072" cy="292608"/>
-          </a:xfrm>
-          <a:prstGeom prst="rect">
-            <a:avLst/>
-          </a:prstGeom>
-          <a:noFill/>
-          <a:ln/>
-        </p:spPr>
-        <p:txBody>
-          <a:bodyPr wrap="square" lIns="0" tIns="0" rIns="0" bIns="0" rtlCol="0" anchor="ctr"/>
-          <a:lstStyle/>
-          <a:p>
-            <a:pPr indent="0" marL="0">
-              <a:buNone/>
-            </a:pPr>
-            <a:r>
-              <a:rPr lang="en-US" sz="1500" dirty="0">
-                <a:solidFill>
-                  <a:srgbClr val="1A1A1A"/>
-                </a:solidFill>
-                <a:latin typeface="Inter" pitchFamily="34" charset="0"/>
-                <a:ea typeface="Inter" pitchFamily="34" charset="-122"/>
-                <a:cs typeface="Inter" pitchFamily="34" charset="-120"/>
-              </a:rPr>
-              <a:t>Who moved it</a:t>
-            </a:r>
-            <a:endParaRPr lang="en-US" sz="1500" dirty="0"/>
-          </a:p>
-        </p:txBody>
-      </p:sp>
-      <p:sp>
-        <p:nvSpPr>
-          <p:cNvPr id="23" name="Shape 21"/>
-          <p:cNvSpPr/>
-          <p:nvPr/>
-        </p:nvSpPr>
-        <p:spPr>
-          <a:xfrm>
-            <a:off x="6355080" y="1691640"/>
-            <a:ext cx="5148072" cy="10973"/>
-          </a:xfrm>
-          <a:prstGeom prst="rect">
-            <a:avLst/>
-          </a:prstGeom>
-          <a:solidFill>
-            <a:srgbClr val="1A1A1A"/>
-          </a:solidFill>
-          <a:ln/>
-        </p:spPr>
-      </p:sp>
-      <p:sp>
-        <p:nvSpPr>
-          <p:cNvPr id="24" name="Text 22"/>
-          <p:cNvSpPr txBox="1"/>
-          <p:nvPr/>
-        </p:nvSpPr>
-        <p:spPr>
-          <a:xfrm>
-            <a:off x="6355080" y="1828800"/>
-            <a:ext cx="2148840" cy="384048"/>
-          </a:xfrm>
-          <a:prstGeom prst="rect">
-            <a:avLst/>
-          </a:prstGeom>
-          <a:noFill/>
-          <a:ln/>
-        </p:spPr>
-        <p:txBody>
-          <a:bodyPr wrap="square" lIns="0" tIns="0" rIns="0" bIns="0" rtlCol="0" anchor="ctr"/>
-          <a:lstStyle/>
-          <a:p>
-            <a:pPr indent="0" marL="0">
-              <a:buNone/>
-            </a:pPr>
-            <a:r>
-              <a:rPr lang="en-US" sz="1400" dirty="0">
-                <a:solidFill>
-                  <a:srgbClr val="1A1A1A"/>
-                </a:solidFill>
-                <a:latin typeface="Inter" pitchFamily="34" charset="0"/>
-                <a:ea typeface="Inter" pitchFamily="34" charset="-122"/>
-                <a:cs typeface="Inter" pitchFamily="34" charset="-120"/>
-              </a:rPr>
-              <a:t>TOYOTA HENDERSON</a:t>
-            </a:r>
-            <a:endParaRPr lang="en-US" sz="1400" dirty="0"/>
-          </a:p>
-        </p:txBody>
-      </p:sp>
-      <p:sp>
-        <p:nvSpPr>
-          <p:cNvPr id="25" name="Shape 23"/>
-          <p:cNvSpPr/>
-          <p:nvPr/>
-        </p:nvSpPr>
-        <p:spPr>
-          <a:xfrm>
-            <a:off x="8595360" y="1929384"/>
-            <a:ext cx="1463040" cy="182880"/>
-          </a:xfrm>
-          <a:prstGeom prst="rect">
-            <a:avLst/>
-          </a:prstGeom>
-          <a:solidFill>
-            <a:srgbClr val="12A566"/>
-          </a:solidFill>
-          <a:ln/>
-        </p:spPr>
-      </p:sp>
-      <p:sp>
-        <p:nvSpPr>
-          <p:cNvPr id="26" name="Text 24"/>
-          <p:cNvSpPr txBox="1"/>
-          <p:nvPr/>
-        </p:nvSpPr>
-        <p:spPr>
-          <a:xfrm>
-            <a:off x="10149840" y="1828800"/>
-            <a:ext cx="1371600" cy="384048"/>
-          </a:xfrm>
-          <a:prstGeom prst="rect">
-            <a:avLst/>
-          </a:prstGeom>
-          <a:noFill/>
-          <a:ln/>
-        </p:spPr>
-        <p:txBody>
-          <a:bodyPr wrap="square" lIns="0" tIns="0" rIns="0" bIns="0" rtlCol="0" anchor="ctr"/>
-          <a:lstStyle/>
-          <a:p>
-            <a:pPr algn="r" indent="0" marL="0">
-              <a:buNone/>
-            </a:pPr>
-            <a:r>
-              <a:rPr lang="en-US" sz="1400" b="1" dirty="0">
-                <a:solidFill>
-                  <a:srgbClr val="0B7A4A"/>
-                </a:solidFill>
-                <a:latin typeface="Inter" pitchFamily="34" charset="0"/>
-                <a:ea typeface="Inter" pitchFamily="34" charset="-122"/>
-                <a:cs typeface="Inter" pitchFamily="34" charset="-120"/>
-              </a:rPr>
-              <a:t>+$1,772,700</a:t>
-            </a:r>
-            <a:endParaRPr lang="en-US" sz="1400" dirty="0"/>
-          </a:p>
-        </p:txBody>
-      </p:sp>
-      <p:sp>
-        <p:nvSpPr>
-          <p:cNvPr id="27" name="Text 25"/>
-          <p:cNvSpPr txBox="1"/>
-          <p:nvPr/>
-        </p:nvSpPr>
-        <p:spPr>
-          <a:xfrm>
-            <a:off x="6355080" y="2258568"/>
-            <a:ext cx="2148840" cy="384048"/>
-          </a:xfrm>
-          <a:prstGeom prst="rect">
-            <a:avLst/>
-          </a:prstGeom>
-          <a:noFill/>
-          <a:ln/>
-        </p:spPr>
-        <p:txBody>
-          <a:bodyPr wrap="square" lIns="0" tIns="0" rIns="0" bIns="0" rtlCol="0" anchor="ctr"/>
-          <a:lstStyle/>
-          <a:p>
-            <a:pPr indent="0" marL="0">
-              <a:buNone/>
-            </a:pPr>
-            <a:r>
-              <a:rPr lang="en-US" sz="1400" dirty="0">
-                <a:solidFill>
-                  <a:srgbClr val="1A1A1A"/>
-                </a:solidFill>
-                <a:latin typeface="Inter" pitchFamily="34" charset="0"/>
-                <a:ea typeface="Inter" pitchFamily="34" charset="-122"/>
-                <a:cs typeface="Inter" pitchFamily="34" charset="-120"/>
-              </a:rPr>
-              <a:t>AUDI HENDERSON</a:t>
-            </a:r>
-            <a:endParaRPr lang="en-US" sz="1400" dirty="0"/>
-          </a:p>
-        </p:txBody>
-      </p:sp>
-      <p:sp>
-        <p:nvSpPr>
-          <p:cNvPr id="28" name="Shape 26"/>
-          <p:cNvSpPr/>
-          <p:nvPr/>
-        </p:nvSpPr>
-        <p:spPr>
-          <a:xfrm>
-            <a:off x="8595360" y="2359152"/>
-            <a:ext cx="1407053" cy="182880"/>
-          </a:xfrm>
-          <a:prstGeom prst="rect">
-            <a:avLst/>
-          </a:prstGeom>
-          <a:solidFill>
-            <a:srgbClr val="12A566"/>
-          </a:solidFill>
-          <a:ln/>
-        </p:spPr>
-      </p:sp>
-      <p:sp>
-        <p:nvSpPr>
-          <p:cNvPr id="29" name="Text 27"/>
-          <p:cNvSpPr txBox="1"/>
-          <p:nvPr/>
-        </p:nvSpPr>
-        <p:spPr>
-          <a:xfrm>
-            <a:off x="10149840" y="2258568"/>
-            <a:ext cx="1371600" cy="384048"/>
-          </a:xfrm>
-          <a:prstGeom prst="rect">
-            <a:avLst/>
-          </a:prstGeom>
-          <a:noFill/>
-          <a:ln/>
-        </p:spPr>
-        <p:txBody>
-          <a:bodyPr wrap="square" lIns="0" tIns="0" rIns="0" bIns="0" rtlCol="0" anchor="ctr"/>
-          <a:lstStyle/>
-          <a:p>
-            <a:pPr algn="r" indent="0" marL="0">
-              <a:buNone/>
-            </a:pPr>
-            <a:r>
-              <a:rPr lang="en-US" sz="1400" b="1" dirty="0">
-                <a:solidFill>
-                  <a:srgbClr val="0B7A4A"/>
-                </a:solidFill>
-                <a:latin typeface="Inter" pitchFamily="34" charset="0"/>
-                <a:ea typeface="Inter" pitchFamily="34" charset="-122"/>
-                <a:cs typeface="Inter" pitchFamily="34" charset="-120"/>
-              </a:rPr>
-              <a:t>+$1,704,863</a:t>
-            </a:r>
-            <a:endParaRPr lang="en-US" sz="1400" dirty="0"/>
-          </a:p>
-        </p:txBody>
-      </p:sp>
-      <p:sp>
-        <p:nvSpPr>
-          <p:cNvPr id="30" name="Text 28"/>
-          <p:cNvSpPr txBox="1"/>
-          <p:nvPr/>
-        </p:nvSpPr>
-        <p:spPr>
-          <a:xfrm>
-            <a:off x="6355080" y="2688336"/>
-            <a:ext cx="2148840" cy="384048"/>
-          </a:xfrm>
-          <a:prstGeom prst="rect">
-            <a:avLst/>
-          </a:prstGeom>
-          <a:noFill/>
-          <a:ln/>
-        </p:spPr>
-        <p:txBody>
-          <a:bodyPr wrap="square" lIns="0" tIns="0" rIns="0" bIns="0" rtlCol="0" anchor="ctr"/>
-          <a:lstStyle/>
-          <a:p>
-            <a:pPr indent="0" marL="0">
-              <a:buNone/>
-            </a:pPr>
-            <a:r>
-              <a:rPr lang="en-US" sz="1400" dirty="0">
-                <a:solidFill>
-                  <a:srgbClr val="1A1A1A"/>
-                </a:solidFill>
-                <a:latin typeface="Inter" pitchFamily="34" charset="0"/>
-                <a:ea typeface="Inter" pitchFamily="34" charset="-122"/>
-                <a:cs typeface="Inter" pitchFamily="34" charset="-120"/>
-              </a:rPr>
-              <a:t>HONDA HENDERSON</a:t>
-            </a:r>
-            <a:endParaRPr lang="en-US" sz="1400" dirty="0"/>
-          </a:p>
-        </p:txBody>
-      </p:sp>
-      <p:sp>
-        <p:nvSpPr>
-          <p:cNvPr id="31" name="Shape 29"/>
-          <p:cNvSpPr/>
-          <p:nvPr/>
-        </p:nvSpPr>
-        <p:spPr>
-          <a:xfrm>
-            <a:off x="8595360" y="2788920"/>
-            <a:ext cx="769067" cy="182880"/>
-          </a:xfrm>
-          <a:prstGeom prst="rect">
-            <a:avLst/>
-          </a:prstGeom>
-          <a:solidFill>
-            <a:srgbClr val="12A566"/>
-          </a:solidFill>
-          <a:ln/>
-        </p:spPr>
-      </p:sp>
-      <p:sp>
-        <p:nvSpPr>
-          <p:cNvPr id="32" name="Text 30"/>
-          <p:cNvSpPr txBox="1"/>
-          <p:nvPr/>
-        </p:nvSpPr>
-        <p:spPr>
-          <a:xfrm>
-            <a:off x="10149840" y="2688336"/>
-            <a:ext cx="1371600" cy="384048"/>
-          </a:xfrm>
-          <a:prstGeom prst="rect">
-            <a:avLst/>
-          </a:prstGeom>
-          <a:noFill/>
-          <a:ln/>
-        </p:spPr>
-        <p:txBody>
-          <a:bodyPr wrap="square" lIns="0" tIns="0" rIns="0" bIns="0" rtlCol="0" anchor="ctr"/>
-          <a:lstStyle/>
-          <a:p>
-            <a:pPr algn="r" indent="0" marL="0">
-              <a:buNone/>
-            </a:pPr>
-            <a:r>
-              <a:rPr lang="en-US" sz="1400" b="1" dirty="0">
-                <a:solidFill>
-                  <a:srgbClr val="0B7A4A"/>
-                </a:solidFill>
-                <a:latin typeface="Inter" pitchFamily="34" charset="0"/>
-                <a:ea typeface="Inter" pitchFamily="34" charset="-122"/>
-                <a:cs typeface="Inter" pitchFamily="34" charset="-120"/>
-              </a:rPr>
-              <a:t>+$931,844</a:t>
-            </a:r>
-            <a:endParaRPr lang="en-US" sz="1400" dirty="0"/>
-          </a:p>
-        </p:txBody>
-      </p:sp>
-      <p:sp>
-        <p:nvSpPr>
-          <p:cNvPr id="33" name="Text 31"/>
-          <p:cNvSpPr txBox="1"/>
-          <p:nvPr/>
-        </p:nvSpPr>
-        <p:spPr>
-          <a:xfrm>
-            <a:off x="6355080" y="3118104"/>
-            <a:ext cx="2148840" cy="384048"/>
-          </a:xfrm>
-          <a:prstGeom prst="rect">
-            <a:avLst/>
-          </a:prstGeom>
-          <a:noFill/>
-          <a:ln/>
-        </p:spPr>
-        <p:txBody>
-          <a:bodyPr wrap="square" lIns="0" tIns="0" rIns="0" bIns="0" rtlCol="0" anchor="ctr"/>
-          <a:lstStyle/>
-          <a:p>
-            <a:pPr indent="0" marL="0">
-              <a:buNone/>
-            </a:pPr>
-            <a:r>
-              <a:rPr lang="en-US" sz="1400" dirty="0">
-                <a:solidFill>
-                  <a:srgbClr val="1A1A1A"/>
-                </a:solidFill>
-                <a:latin typeface="Inter" pitchFamily="34" charset="0"/>
-                <a:ea typeface="Inter" pitchFamily="34" charset="-122"/>
-                <a:cs typeface="Inter" pitchFamily="34" charset="-120"/>
-              </a:rPr>
-              <a:t>LEXUS</a:t>
-            </a:r>
-            <a:endParaRPr lang="en-US" sz="1400" dirty="0"/>
-          </a:p>
-        </p:txBody>
-      </p:sp>
-      <p:sp>
-        <p:nvSpPr>
-          <p:cNvPr id="34" name="Shape 32"/>
-          <p:cNvSpPr/>
-          <p:nvPr/>
-        </p:nvSpPr>
-        <p:spPr>
-          <a:xfrm>
-            <a:off x="8595360" y="3218688"/>
-            <a:ext cx="630324" cy="182880"/>
-          </a:xfrm>
-          <a:prstGeom prst="rect">
-            <a:avLst/>
-          </a:prstGeom>
-          <a:solidFill>
-            <a:srgbClr val="12A566"/>
-          </a:solidFill>
-          <a:ln/>
-        </p:spPr>
-      </p:sp>
-      <p:sp>
-        <p:nvSpPr>
-          <p:cNvPr id="35" name="Text 33"/>
-          <p:cNvSpPr txBox="1"/>
-          <p:nvPr/>
-        </p:nvSpPr>
-        <p:spPr>
-          <a:xfrm>
-            <a:off x="10149840" y="3118104"/>
-            <a:ext cx="1371600" cy="384048"/>
-          </a:xfrm>
-          <a:prstGeom prst="rect">
-            <a:avLst/>
-          </a:prstGeom>
-          <a:noFill/>
-          <a:ln/>
-        </p:spPr>
-        <p:txBody>
-          <a:bodyPr wrap="square" lIns="0" tIns="0" rIns="0" bIns="0" rtlCol="0" anchor="ctr"/>
-          <a:lstStyle/>
-          <a:p>
-            <a:pPr algn="r" indent="0" marL="0">
-              <a:buNone/>
-            </a:pPr>
-            <a:r>
-              <a:rPr lang="en-US" sz="1400" b="1" dirty="0">
-                <a:solidFill>
-                  <a:srgbClr val="0B7A4A"/>
-                </a:solidFill>
-                <a:latin typeface="Inter" pitchFamily="34" charset="0"/>
-                <a:ea typeface="Inter" pitchFamily="34" charset="-122"/>
-                <a:cs typeface="Inter" pitchFamily="34" charset="-120"/>
-              </a:rPr>
-              <a:t>+$763,736</a:t>
-            </a:r>
-            <a:endParaRPr lang="en-US" sz="1400" dirty="0"/>
-          </a:p>
-        </p:txBody>
-      </p:sp>
-      <p:sp>
-        <p:nvSpPr>
-          <p:cNvPr id="36" name="Text 34"/>
-          <p:cNvSpPr txBox="1"/>
-          <p:nvPr/>
-        </p:nvSpPr>
-        <p:spPr>
-          <a:xfrm>
-            <a:off x="6355080" y="3547872"/>
-            <a:ext cx="2148840" cy="384048"/>
-          </a:xfrm>
-          <a:prstGeom prst="rect">
-            <a:avLst/>
-          </a:prstGeom>
-          <a:noFill/>
-          <a:ln/>
-        </p:spPr>
-        <p:txBody>
-          <a:bodyPr wrap="square" lIns="0" tIns="0" rIns="0" bIns="0" rtlCol="0" anchor="ctr"/>
-          <a:lstStyle/>
-          <a:p>
-            <a:pPr indent="0" marL="0">
-              <a:buNone/>
-            </a:pPr>
-            <a:r>
-              <a:rPr lang="en-US" sz="1400" dirty="0">
-                <a:solidFill>
-                  <a:srgbClr val="1A1A1A"/>
-                </a:solidFill>
-                <a:latin typeface="Inter" pitchFamily="34" charset="0"/>
-                <a:ea typeface="Inter" pitchFamily="34" charset="-122"/>
-                <a:cs typeface="Inter" pitchFamily="34" charset="-120"/>
-              </a:rPr>
-              <a:t>LINCOLN</a:t>
-            </a:r>
-            <a:endParaRPr lang="en-US" sz="1400" dirty="0"/>
-          </a:p>
-        </p:txBody>
-      </p:sp>
-      <p:sp>
-        <p:nvSpPr>
-          <p:cNvPr id="37" name="Shape 35"/>
-          <p:cNvSpPr/>
-          <p:nvPr/>
-        </p:nvSpPr>
-        <p:spPr>
-          <a:xfrm>
-            <a:off x="8595360" y="3648456"/>
-            <a:ext cx="592076" cy="182880"/>
-          </a:xfrm>
-          <a:prstGeom prst="rect">
-            <a:avLst/>
-          </a:prstGeom>
-          <a:solidFill>
-            <a:srgbClr val="12A566"/>
-          </a:solidFill>
-          <a:ln/>
-        </p:spPr>
-      </p:sp>
-      <p:sp>
-        <p:nvSpPr>
-          <p:cNvPr id="38" name="Text 36"/>
-          <p:cNvSpPr txBox="1"/>
-          <p:nvPr/>
-        </p:nvSpPr>
-        <p:spPr>
-          <a:xfrm>
-            <a:off x="10149840" y="3547872"/>
-            <a:ext cx="1371600" cy="384048"/>
-          </a:xfrm>
-          <a:prstGeom prst="rect">
-            <a:avLst/>
-          </a:prstGeom>
-          <a:noFill/>
-          <a:ln/>
-        </p:spPr>
-        <p:txBody>
-          <a:bodyPr wrap="square" lIns="0" tIns="0" rIns="0" bIns="0" rtlCol="0" anchor="ctr"/>
-          <a:lstStyle/>
-          <a:p>
-            <a:pPr algn="r" indent="0" marL="0">
-              <a:buNone/>
-            </a:pPr>
-            <a:r>
-              <a:rPr lang="en-US" sz="1400" b="1" dirty="0">
-                <a:solidFill>
-                  <a:srgbClr val="0B7A4A"/>
-                </a:solidFill>
-                <a:latin typeface="Inter" pitchFamily="34" charset="0"/>
-                <a:ea typeface="Inter" pitchFamily="34" charset="-122"/>
-                <a:cs typeface="Inter" pitchFamily="34" charset="-120"/>
-              </a:rPr>
-              <a:t>+$717,392</a:t>
-            </a:r>
-            <a:endParaRPr lang="en-US" sz="1400" dirty="0"/>
-          </a:p>
-        </p:txBody>
-      </p:sp>
-      <p:sp>
-        <p:nvSpPr>
-          <p:cNvPr id="39" name="Text 37"/>
-          <p:cNvSpPr txBox="1"/>
-          <p:nvPr/>
-        </p:nvSpPr>
-        <p:spPr>
-          <a:xfrm>
-            <a:off x="6355080" y="3977640"/>
-            <a:ext cx="2148840" cy="384048"/>
-          </a:xfrm>
-          <a:prstGeom prst="rect">
-            <a:avLst/>
-          </a:prstGeom>
-          <a:noFill/>
-          <a:ln/>
-        </p:spPr>
-        <p:txBody>
-          <a:bodyPr wrap="square" lIns="0" tIns="0" rIns="0" bIns="0" rtlCol="0" anchor="ctr"/>
-          <a:lstStyle/>
-          <a:p>
-            <a:pPr indent="0" marL="0">
-              <a:buNone/>
-            </a:pPr>
-            <a:r>
-              <a:rPr lang="en-US" sz="1400" dirty="0">
-                <a:solidFill>
-                  <a:srgbClr val="1A1A1A"/>
-                </a:solidFill>
-                <a:latin typeface="Inter" pitchFamily="34" charset="0"/>
-                <a:ea typeface="Inter" pitchFamily="34" charset="-122"/>
-                <a:cs typeface="Inter" pitchFamily="34" charset="-120"/>
-              </a:rPr>
-              <a:t>ACURA</a:t>
-            </a:r>
-            <a:endParaRPr lang="en-US" sz="1400" dirty="0"/>
-          </a:p>
-        </p:txBody>
-      </p:sp>
-      <p:sp>
-        <p:nvSpPr>
-          <p:cNvPr id="40" name="Shape 38"/>
-          <p:cNvSpPr/>
-          <p:nvPr/>
-        </p:nvSpPr>
-        <p:spPr>
-          <a:xfrm>
-            <a:off x="8168846" y="4078224"/>
-            <a:ext cx="426514" cy="182880"/>
-          </a:xfrm>
-          <a:prstGeom prst="rect">
-            <a:avLst/>
-          </a:prstGeom>
-          <a:solidFill>
-            <a:srgbClr val="C2352F"/>
-          </a:solidFill>
-          <a:ln/>
-        </p:spPr>
-      </p:sp>
-      <p:sp>
-        <p:nvSpPr>
-          <p:cNvPr id="41" name="Text 39"/>
-          <p:cNvSpPr txBox="1"/>
-          <p:nvPr/>
-        </p:nvSpPr>
-        <p:spPr>
-          <a:xfrm>
-            <a:off x="10149840" y="3977640"/>
-            <a:ext cx="1371600" cy="384048"/>
-          </a:xfrm>
-          <a:prstGeom prst="rect">
-            <a:avLst/>
-          </a:prstGeom>
-          <a:noFill/>
-          <a:ln/>
-        </p:spPr>
-        <p:txBody>
-          <a:bodyPr wrap="square" lIns="0" tIns="0" rIns="0" bIns="0" rtlCol="0" anchor="ctr"/>
-          <a:lstStyle/>
-          <a:p>
-            <a:pPr algn="r" indent="0" marL="0">
-              <a:buNone/>
-            </a:pPr>
-            <a:r>
-              <a:rPr lang="en-US" sz="1400" b="1" dirty="0">
-                <a:solidFill>
-                  <a:srgbClr val="A82B26"/>
-                </a:solidFill>
-                <a:latin typeface="Inter" pitchFamily="34" charset="0"/>
-                <a:ea typeface="Inter" pitchFamily="34" charset="-122"/>
-                <a:cs typeface="Inter" pitchFamily="34" charset="-120"/>
-              </a:rPr>
-              <a:t>−$516,788</a:t>
-            </a:r>
-            <a:endParaRPr lang="en-US" sz="1400" dirty="0"/>
-          </a:p>
-        </p:txBody>
-      </p:sp>
-      <p:sp>
-        <p:nvSpPr>
-          <p:cNvPr id="42" name="Text 40"/>
-          <p:cNvSpPr txBox="1"/>
-          <p:nvPr/>
-        </p:nvSpPr>
-        <p:spPr>
-          <a:xfrm>
-            <a:off x="6355080" y="4407408"/>
-            <a:ext cx="2148840" cy="384048"/>
-          </a:xfrm>
-          <a:prstGeom prst="rect">
-            <a:avLst/>
-          </a:prstGeom>
-          <a:noFill/>
-          <a:ln/>
-        </p:spPr>
-        <p:txBody>
-          <a:bodyPr wrap="square" lIns="0" tIns="0" rIns="0" bIns="0" rtlCol="0" anchor="ctr"/>
-          <a:lstStyle/>
-          <a:p>
-            <a:pPr indent="0" marL="0">
-              <a:buNone/>
-            </a:pPr>
-            <a:r>
-              <a:rPr lang="en-US" sz="1400" dirty="0">
-                <a:solidFill>
-                  <a:srgbClr val="1A1A1A"/>
-                </a:solidFill>
-                <a:latin typeface="Inter" pitchFamily="34" charset="0"/>
-                <a:ea typeface="Inter" pitchFamily="34" charset="-122"/>
-                <a:cs typeface="Inter" pitchFamily="34" charset="-120"/>
-              </a:rPr>
-              <a:t>AUDI RENO</a:t>
-            </a:r>
-            <a:endParaRPr lang="en-US" sz="1400" dirty="0"/>
-          </a:p>
-        </p:txBody>
-      </p:sp>
-      <p:sp>
-        <p:nvSpPr>
-          <p:cNvPr id="43" name="Shape 41"/>
-          <p:cNvSpPr/>
-          <p:nvPr/>
-        </p:nvSpPr>
-        <p:spPr>
-          <a:xfrm>
-            <a:off x="8166323" y="4507992"/>
-            <a:ext cx="429037" cy="182880"/>
-          </a:xfrm>
-          <a:prstGeom prst="rect">
-            <a:avLst/>
-          </a:prstGeom>
-          <a:solidFill>
-            <a:srgbClr val="C2352F"/>
-          </a:solidFill>
-          <a:ln/>
-        </p:spPr>
-      </p:sp>
-      <p:sp>
-        <p:nvSpPr>
-          <p:cNvPr id="44" name="Text 42"/>
-          <p:cNvSpPr txBox="1"/>
-          <p:nvPr/>
-        </p:nvSpPr>
-        <p:spPr>
-          <a:xfrm>
-            <a:off x="10149840" y="4407408"/>
-            <a:ext cx="1371600" cy="384048"/>
-          </a:xfrm>
-          <a:prstGeom prst="rect">
-            <a:avLst/>
-          </a:prstGeom>
-          <a:noFill/>
-          <a:ln/>
-        </p:spPr>
-        <p:txBody>
-          <a:bodyPr wrap="square" lIns="0" tIns="0" rIns="0" bIns="0" rtlCol="0" anchor="ctr"/>
-          <a:lstStyle/>
-          <a:p>
-            <a:pPr algn="r" indent="0" marL="0">
-              <a:buNone/>
-            </a:pPr>
-            <a:r>
-              <a:rPr lang="en-US" sz="1400" b="1" dirty="0">
-                <a:solidFill>
-                  <a:srgbClr val="A82B26"/>
-                </a:solidFill>
-                <a:latin typeface="Inter" pitchFamily="34" charset="0"/>
-                <a:ea typeface="Inter" pitchFamily="34" charset="-122"/>
-                <a:cs typeface="Inter" pitchFamily="34" charset="-120"/>
-              </a:rPr>
-              <a:t>−$519,845</a:t>
-            </a:r>
-            <a:endParaRPr lang="en-US" sz="1400" dirty="0"/>
-          </a:p>
-        </p:txBody>
-      </p:sp>
-      <p:sp>
-        <p:nvSpPr>
-          <p:cNvPr id="45" name="Text 43"/>
-          <p:cNvSpPr txBox="1"/>
-          <p:nvPr/>
-        </p:nvSpPr>
-        <p:spPr>
-          <a:xfrm>
-            <a:off x="6355080" y="4837176"/>
-            <a:ext cx="2148840" cy="384048"/>
-          </a:xfrm>
-          <a:prstGeom prst="rect">
-            <a:avLst/>
-          </a:prstGeom>
-          <a:noFill/>
-          <a:ln/>
-        </p:spPr>
-        <p:txBody>
-          <a:bodyPr wrap="square" lIns="0" tIns="0" rIns="0" bIns="0" rtlCol="0" anchor="ctr"/>
-          <a:lstStyle/>
-          <a:p>
-            <a:pPr indent="0" marL="0">
-              <a:buNone/>
-            </a:pPr>
-            <a:r>
-              <a:rPr lang="en-US" sz="1400" dirty="0">
-                <a:solidFill>
-                  <a:srgbClr val="1A1A1A"/>
-                </a:solidFill>
-                <a:latin typeface="Inter" pitchFamily="34" charset="0"/>
-                <a:ea typeface="Inter" pitchFamily="34" charset="-122"/>
-                <a:cs typeface="Inter" pitchFamily="34" charset="-120"/>
-              </a:rPr>
-              <a:t>VW HENDERSON</a:t>
-            </a:r>
-            <a:endParaRPr lang="en-US" sz="1400" dirty="0"/>
-          </a:p>
-        </p:txBody>
-      </p:sp>
-      <p:sp>
-        <p:nvSpPr>
-          <p:cNvPr id="46" name="Shape 44"/>
-          <p:cNvSpPr/>
-          <p:nvPr/>
-        </p:nvSpPr>
-        <p:spPr>
-          <a:xfrm>
-            <a:off x="7967135" y="4937760"/>
-            <a:ext cx="628225" cy="182880"/>
-          </a:xfrm>
-          <a:prstGeom prst="rect">
-            <a:avLst/>
-          </a:prstGeom>
-          <a:solidFill>
-            <a:srgbClr val="C2352F"/>
-          </a:solidFill>
-          <a:ln/>
-        </p:spPr>
-      </p:sp>
-      <p:sp>
-        <p:nvSpPr>
-          <p:cNvPr id="47" name="Text 45"/>
-          <p:cNvSpPr txBox="1"/>
-          <p:nvPr/>
-        </p:nvSpPr>
-        <p:spPr>
-          <a:xfrm>
-            <a:off x="10149840" y="4837176"/>
-            <a:ext cx="1371600" cy="384048"/>
-          </a:xfrm>
-          <a:prstGeom prst="rect">
-            <a:avLst/>
-          </a:prstGeom>
-          <a:noFill/>
-          <a:ln/>
-        </p:spPr>
-        <p:txBody>
-          <a:bodyPr wrap="square" lIns="0" tIns="0" rIns="0" bIns="0" rtlCol="0" anchor="ctr"/>
-          <a:lstStyle/>
-          <a:p>
-            <a:pPr algn="r" indent="0" marL="0">
-              <a:buNone/>
-            </a:pPr>
-            <a:r>
-              <a:rPr lang="en-US" sz="1400" b="1" dirty="0">
-                <a:solidFill>
-                  <a:srgbClr val="A82B26"/>
-                </a:solidFill>
-                <a:latin typeface="Inter" pitchFamily="34" charset="0"/>
-                <a:ea typeface="Inter" pitchFamily="34" charset="-122"/>
-                <a:cs typeface="Inter" pitchFamily="34" charset="-120"/>
-              </a:rPr>
-              <a:t>−$761,192</a:t>
-            </a:r>
-            <a:endParaRPr lang="en-US" sz="1400" dirty="0"/>
-          </a:p>
-        </p:txBody>
-      </p:sp>
-      <p:sp>
-        <p:nvSpPr>
-          <p:cNvPr id="48" name="Text 46"/>
-          <p:cNvSpPr txBox="1"/>
-          <p:nvPr/>
-        </p:nvSpPr>
-        <p:spPr>
-          <a:xfrm>
-            <a:off x="6355080" y="5266944"/>
-            <a:ext cx="2148840" cy="384048"/>
-          </a:xfrm>
-          <a:prstGeom prst="rect">
-            <a:avLst/>
-          </a:prstGeom>
-          <a:noFill/>
-          <a:ln/>
-        </p:spPr>
-        <p:txBody>
-          <a:bodyPr wrap="square" lIns="0" tIns="0" rIns="0" bIns="0" rtlCol="0" anchor="ctr"/>
-          <a:lstStyle/>
-          <a:p>
-            <a:pPr indent="0" marL="0">
-              <a:buNone/>
-            </a:pPr>
-            <a:r>
-              <a:rPr lang="en-US" sz="1400" dirty="0">
-                <a:solidFill>
-                  <a:srgbClr val="1A1A1A"/>
-                </a:solidFill>
-                <a:latin typeface="Inter" pitchFamily="34" charset="0"/>
-                <a:ea typeface="Inter" pitchFamily="34" charset="-122"/>
-                <a:cs typeface="Inter" pitchFamily="34" charset="-120"/>
-              </a:rPr>
-              <a:t>HONDA NORTH</a:t>
-            </a:r>
-            <a:endParaRPr lang="en-US" sz="1400" dirty="0"/>
-          </a:p>
-        </p:txBody>
-      </p:sp>
-      <p:sp>
-        <p:nvSpPr>
-          <p:cNvPr id="49" name="Shape 47"/>
-          <p:cNvSpPr/>
-          <p:nvPr/>
-        </p:nvSpPr>
-        <p:spPr>
-          <a:xfrm>
-            <a:off x="7902183" y="5367528"/>
-            <a:ext cx="693177" cy="182880"/>
-          </a:xfrm>
-          <a:prstGeom prst="rect">
-            <a:avLst/>
-          </a:prstGeom>
-          <a:solidFill>
-            <a:srgbClr val="C2352F"/>
-          </a:solidFill>
-          <a:ln/>
-        </p:spPr>
-      </p:sp>
-      <p:sp>
-        <p:nvSpPr>
-          <p:cNvPr id="50" name="Text 48"/>
-          <p:cNvSpPr txBox="1"/>
-          <p:nvPr/>
-        </p:nvSpPr>
-        <p:spPr>
-          <a:xfrm>
-            <a:off x="10149840" y="5266944"/>
-            <a:ext cx="1371600" cy="384048"/>
-          </a:xfrm>
-          <a:prstGeom prst="rect">
-            <a:avLst/>
-          </a:prstGeom>
-          <a:noFill/>
-          <a:ln/>
-        </p:spPr>
-        <p:txBody>
-          <a:bodyPr wrap="square" lIns="0" tIns="0" rIns="0" bIns="0" rtlCol="0" anchor="ctr"/>
-          <a:lstStyle/>
-          <a:p>
-            <a:pPr algn="r" indent="0" marL="0">
-              <a:buNone/>
-            </a:pPr>
-            <a:r>
-              <a:rPr lang="en-US" sz="1400" b="1" dirty="0">
-                <a:solidFill>
-                  <a:srgbClr val="A82B26"/>
-                </a:solidFill>
-                <a:latin typeface="Inter" pitchFamily="34" charset="0"/>
-                <a:ea typeface="Inter" pitchFamily="34" charset="-122"/>
-                <a:cs typeface="Inter" pitchFamily="34" charset="-120"/>
-              </a:rPr>
-              <a:t>−$839,891</a:t>
-            </a:r>
-            <a:endParaRPr lang="en-US" sz="1400" dirty="0"/>
-          </a:p>
-        </p:txBody>
-      </p:sp>
-      <p:sp>
-        <p:nvSpPr>
-          <p:cNvPr id="51" name="Shape 49"/>
-          <p:cNvSpPr/>
-          <p:nvPr/>
-        </p:nvSpPr>
-        <p:spPr>
-          <a:xfrm>
-            <a:off x="8589874" y="1828800"/>
-            <a:ext cx="10973" cy="3813048"/>
-          </a:xfrm>
-          <a:prstGeom prst="rect">
-            <a:avLst/>
-          </a:prstGeom>
-          <a:solidFill>
-            <a:srgbClr val="9AA3AD"/>
-          </a:solidFill>
-          <a:ln/>
-        </p:spPr>
-      </p:sp>
-      <p:sp>
-        <p:nvSpPr>
-          <p:cNvPr id="52" name="Shape 50"/>
-          <p:cNvSpPr/>
-          <p:nvPr/>
-        </p:nvSpPr>
-        <p:spPr>
-          <a:xfrm>
-            <a:off x="457200" y="6126480"/>
-            <a:ext cx="11274552" cy="371856"/>
-          </a:xfrm>
-          <a:prstGeom prst="rect">
-            <a:avLst/>
-          </a:prstGeom>
-          <a:solidFill>
-            <a:srgbClr val="E6F6EE"/>
-          </a:solidFill>
-          <a:ln/>
-        </p:spPr>
-      </p:sp>
-      <p:sp>
-        <p:nvSpPr>
-          <p:cNvPr id="53" name="Text 51"/>
-          <p:cNvSpPr txBox="1"/>
-          <p:nvPr/>
-        </p:nvSpPr>
-        <p:spPr>
-          <a:xfrm>
-            <a:off x="658368" y="6144768"/>
-            <a:ext cx="10927080" cy="335280"/>
-          </a:xfrm>
-          <a:prstGeom prst="rect">
-            <a:avLst/>
-          </a:prstGeom>
-          <a:noFill/>
-          <a:ln/>
-        </p:spPr>
-        <p:txBody>
-          <a:bodyPr wrap="square" lIns="0" tIns="0" rIns="0" bIns="0" rtlCol="0" anchor="ctr"/>
-          <a:lstStyle/>
-          <a:p>
-            <a:pPr indent="0" marL="0">
-              <a:buNone/>
-            </a:pPr>
-            <a:r>
-              <a:rPr lang="en-US" sz="1600" b="1" dirty="0">
-                <a:solidFill>
-                  <a:srgbClr val="0B7A4A"/>
-                </a:solidFill>
-                <a:latin typeface="Inter" pitchFamily="34" charset="0"/>
-                <a:ea typeface="Inter" pitchFamily="34" charset="-122"/>
-                <a:cs typeface="Inter" pitchFamily="34" charset="-120"/>
-              </a:rPr>
-              <a:t>Five stores added +$5,890,534; the bottom four gave back $2,637,716.</a:t>
+              <a:t>Ask Hyundai Prescott, Lincoln and Lexus what changed. Ask Acura, VW St George and VW Henderson what got in the way.</a:t>
             </a:r>
             <a:endParaRPr lang="en-US" sz="1600" dirty="0"/>
           </a:p>

</xml_diff>

<commit_message>
Day 2 deck: change marks on gross YOY rankers now vertical, right of the percent
Co-Authored-By: Claude Opus 5.5 <noreply@anthropic.com>
Claude-Session: https://claude.ai/code/session_01Xa4nFVxuQGXmHARGph9WhS
</commit_message>
<xml_diff>
--- a/day2-deck/decks/Fixed Ops Gross - House Style.pptx
+++ b/day2-deck/decks/Fixed Ops Gross - House Style.pptx
@@ -13765,8 +13765,8 @@
         </p:nvSpPr>
         <p:spPr>
           <a:xfrm>
-            <a:off x="5020056" y="2201284"/>
-            <a:ext cx="182880" cy="64008"/>
+            <a:off x="5907024" y="2167128"/>
+            <a:ext cx="54864" cy="132319"/>
           </a:xfrm>
           <a:prstGeom prst="rect">
             <a:avLst/>
@@ -14489,8 +14489,8 @@
         </p:nvSpPr>
         <p:spPr>
           <a:xfrm>
-            <a:off x="5020056" y="3096320"/>
-            <a:ext cx="182880" cy="64008"/>
+            <a:off x="5907024" y="3062164"/>
+            <a:ext cx="54864" cy="132319"/>
           </a:xfrm>
           <a:prstGeom prst="rect">
             <a:avLst/>
@@ -14685,8 +14685,8 @@
         </p:nvSpPr>
         <p:spPr>
           <a:xfrm>
-            <a:off x="5020056" y="3320079"/>
-            <a:ext cx="182880" cy="64008"/>
+            <a:off x="5907024" y="3285923"/>
+            <a:ext cx="54864" cy="132319"/>
           </a:xfrm>
           <a:prstGeom prst="rect">
             <a:avLst/>
@@ -18929,8 +18929,8 @@
         </p:nvSpPr>
         <p:spPr>
           <a:xfrm>
-            <a:off x="10570464" y="4886392"/>
-            <a:ext cx="182880" cy="64008"/>
+            <a:off x="11457432" y="4852237"/>
+            <a:ext cx="54864" cy="132319"/>
           </a:xfrm>
           <a:prstGeom prst="rect">
             <a:avLst/>
@@ -19125,8 +19125,8 @@
         </p:nvSpPr>
         <p:spPr>
           <a:xfrm>
-            <a:off x="10570464" y="5110151"/>
-            <a:ext cx="182880" cy="64008"/>
+            <a:off x="11457432" y="5075996"/>
+            <a:ext cx="54864" cy="132319"/>
           </a:xfrm>
           <a:prstGeom prst="rect">
             <a:avLst/>
@@ -19497,8 +19497,8 @@
         </p:nvSpPr>
         <p:spPr>
           <a:xfrm>
-            <a:off x="10570464" y="5557669"/>
-            <a:ext cx="182880" cy="64008"/>
+            <a:off x="11457432" y="5523514"/>
+            <a:ext cx="54864" cy="132319"/>
           </a:xfrm>
           <a:prstGeom prst="rect">
             <a:avLst/>
@@ -29602,8 +29602,8 @@
         </p:nvSpPr>
         <p:spPr>
           <a:xfrm>
-            <a:off x="5020056" y="2872561"/>
-            <a:ext cx="182880" cy="64008"/>
+            <a:off x="5907024" y="2838405"/>
+            <a:ext cx="54864" cy="132319"/>
           </a:xfrm>
           <a:prstGeom prst="rect">
             <a:avLst/>
@@ -29798,8 +29798,8 @@
         </p:nvSpPr>
         <p:spPr>
           <a:xfrm>
-            <a:off x="5020056" y="3096320"/>
-            <a:ext cx="182880" cy="64008"/>
+            <a:off x="5907024" y="3062164"/>
+            <a:ext cx="54864" cy="132319"/>
           </a:xfrm>
           <a:prstGeom prst="rect">
             <a:avLst/>
@@ -31050,8 +31050,8 @@
         </p:nvSpPr>
         <p:spPr>
           <a:xfrm>
-            <a:off x="5020056" y="4662633"/>
-            <a:ext cx="182880" cy="64008"/>
+            <a:off x="5907024" y="4628478"/>
+            <a:ext cx="54864" cy="132319"/>
           </a:xfrm>
           <a:prstGeom prst="rect">
             <a:avLst/>
@@ -33534,8 +33534,8 @@
         </p:nvSpPr>
         <p:spPr>
           <a:xfrm>
-            <a:off x="10570464" y="3991356"/>
-            <a:ext cx="182880" cy="64008"/>
+            <a:off x="11457432" y="3957200"/>
+            <a:ext cx="54864" cy="132319"/>
           </a:xfrm>
           <a:prstGeom prst="rect">
             <a:avLst/>
@@ -34258,8 +34258,8 @@
         </p:nvSpPr>
         <p:spPr>
           <a:xfrm>
-            <a:off x="10570464" y="4886392"/>
-            <a:ext cx="182880" cy="64008"/>
+            <a:off x="11457432" y="4852237"/>
+            <a:ext cx="54864" cy="132319"/>
           </a:xfrm>
           <a:prstGeom prst="rect">
             <a:avLst/>
@@ -34630,8 +34630,8 @@
         </p:nvSpPr>
         <p:spPr>
           <a:xfrm>
-            <a:off x="10570464" y="5333910"/>
-            <a:ext cx="182880" cy="64008"/>
+            <a:off x="11457432" y="5299755"/>
+            <a:ext cx="54864" cy="132319"/>
           </a:xfrm>
           <a:prstGeom prst="rect">
             <a:avLst/>
@@ -44759,8 +44759,8 @@
         </p:nvSpPr>
         <p:spPr>
           <a:xfrm>
-            <a:off x="5020056" y="2648802"/>
-            <a:ext cx="182880" cy="64008"/>
+            <a:off x="5907024" y="2614646"/>
+            <a:ext cx="54864" cy="132319"/>
           </a:xfrm>
           <a:prstGeom prst="rect">
             <a:avLst/>
@@ -45483,8 +45483,8 @@
         </p:nvSpPr>
         <p:spPr>
           <a:xfrm>
-            <a:off x="5020056" y="3543838"/>
-            <a:ext cx="182880" cy="64008"/>
+            <a:off x="5907024" y="3509682"/>
+            <a:ext cx="54864" cy="132319"/>
           </a:xfrm>
           <a:prstGeom prst="rect">
             <a:avLst/>
@@ -46031,8 +46031,8 @@
         </p:nvSpPr>
         <p:spPr>
           <a:xfrm>
-            <a:off x="5020056" y="4215115"/>
-            <a:ext cx="182880" cy="64008"/>
+            <a:off x="5907024" y="4180960"/>
+            <a:ext cx="54864" cy="132319"/>
           </a:xfrm>
           <a:prstGeom prst="rect">
             <a:avLst/>
@@ -49043,8 +49043,8 @@
         </p:nvSpPr>
         <p:spPr>
           <a:xfrm>
-            <a:off x="10570464" y="4215115"/>
-            <a:ext cx="182880" cy="64008"/>
+            <a:off x="11457432" y="4180960"/>
+            <a:ext cx="54864" cy="132319"/>
           </a:xfrm>
           <a:prstGeom prst="rect">
             <a:avLst/>
@@ -49767,8 +49767,8 @@
         </p:nvSpPr>
         <p:spPr>
           <a:xfrm>
-            <a:off x="10570464" y="5110151"/>
-            <a:ext cx="182880" cy="64008"/>
+            <a:off x="11457432" y="5075996"/>
+            <a:ext cx="54864" cy="132319"/>
           </a:xfrm>
           <a:prstGeom prst="rect">
             <a:avLst/>
@@ -49963,8 +49963,8 @@
         </p:nvSpPr>
         <p:spPr>
           <a:xfrm>
-            <a:off x="10570464" y="5333910"/>
-            <a:ext cx="182880" cy="64008"/>
+            <a:off x="11457432" y="5299755"/>
+            <a:ext cx="54864" cy="132319"/>
           </a:xfrm>
           <a:prstGeom prst="rect">
             <a:avLst/>

</xml_diff>

<commit_message>
Movers: moving-now column reads Q3 vs Q1, this year
Co-Authored-By: Claude Opus 5.5 <noreply@anthropic.com>
Claude-Session: https://claude.ai/code/session_01Xa4nFVxuQGXmHARGph9WhS
</commit_message>
<xml_diff>
--- a/day2-deck/decks/Fixed Ops Gross - House Style.pptx
+++ b/day2-deck/decks/Fixed Ops Gross - House Style.pptx
@@ -21697,7 +21697,7 @@
                 <a:ea typeface="Inter" pitchFamily="34" charset="-122"/>
                 <a:cs typeface="Inter" pitchFamily="34" charset="-120"/>
               </a:rPr>
-              <a:t>Jul–Sep vs Jan–Mar this year</a:t>
+              <a:t>Q3 vs Q1, this year</a:t>
             </a:r>
             <a:endParaRPr lang="en-US" sz="1200" dirty="0"/>
           </a:p>
@@ -36908,7 +36908,7 @@
                 <a:ea typeface="Inter" pitchFamily="34" charset="-122"/>
                 <a:cs typeface="Inter" pitchFamily="34" charset="-120"/>
               </a:rPr>
-              <a:t>Jul–Sep vs Jan–Mar this year</a:t>
+              <a:t>Q3 vs Q1, this year</a:t>
             </a:r>
             <a:endParaRPr lang="en-US" sz="1200" dirty="0"/>
           </a:p>
@@ -52123,7 +52123,7 @@
                 <a:ea typeface="Inter" pitchFamily="34" charset="-122"/>
                 <a:cs typeface="Inter" pitchFamily="34" charset="-120"/>
               </a:rPr>
-              <a:t>Jul–Sep vs Jan–Mar this year</a:t>
+              <a:t>Q3 vs Q1, this year</a:t>
             </a:r>
             <a:endParaRPr lang="en-US" sz="1200" dirty="0"/>
           </a:p>

</xml_diff>